<commit_message>
Deck: business context (problem, operator patterns, why now) and measured KPIs
Adds three slides before the solution: why Northbay needs this (analog gauges,
photos are not readings, cost of late readings; ETH Zurich ICRA 2024, Siemens
2024), what we hear from energy operators (anonymised patterns -> answers) and
why now. Outcome cards now use measured build numbers; demo adds the AI model
& usage step; Northbay Energy branding throughout.

Co-authored-by: Isaac <no-reply@databricks.com>
</commit_message>
<xml_diff>
--- a/deck/pressure-gauge-reader.pptx
+++ b/deck/pressure-gauge-reader.pptx
@@ -19,6 +19,9 @@
     <p:sldId id="263" r:id="rId24"/>
     <p:sldId id="264" r:id="rId25"/>
     <p:sldId id="265" r:id="rId26"/>
+    <p:sldId id="266" r:id="rId27"/>
+    <p:sldId id="267" r:id="rId28"/>
+    <p:sldId id="268" r:id="rId29"/>
   </p:sldIdLst>
   <p:sldSz cy="6858000" cx="12188950"/>
   <p:notesSz cx="6858000" cy="9144000"/>
@@ -762,7 +765,7 @@
           <a:lstStyle/>
           <a:p>
             <a:r>
-              <a:t>Open with the customer and the business persona: operations leadership at a refinery running robot inspection rounds.</a:t>
+              <a:t>Northbay Energy is a fictional operator (one refinery, one terminal) built on synthetic metadata and publicly licensed gauge photos. Open with the business persona: operations leadership running robot inspection rounds.</a:t>
             </a:r>
           </a:p>
         </p:txBody>
@@ -878,7 +881,7 @@
           <a:lstStyle/>
           <a:p>
             <a:r>
-              <a:t>Replace [TBD] with the impact model: rounds/day x gauges x minutes x loaded cost. '&lt; 5 minutes' is from the build run (~4 minutes for 30 images).</a:t>
+              <a:t>Business context first. Analog gauges persist because brownfield retrofits are expensive and slow; robots solve the walking, not the reading. The ICRA paper lists reflections, dirt, mounting angles and the variety of dial designs as why gauge reading is hard for computer vision. Siemens: an average large plant still loses 27 hours a month to unplanned downtime.</a:t>
             </a:r>
           </a:p>
         </p:txBody>
@@ -936,7 +939,7 @@
           <a:lstStyle/>
           <a:p>
             <a:r>
-              <a:t>Frame value for both personas the AI roleplay will play: the business stakeholder and the technical/domain stakeholder.</a:t>
+              <a:t>Generalised from robot gauge-reading programmes at energy operators (no customer names). Use this slide to show discovery skills: each answer maps to something visible in the demo.</a:t>
             </a:r>
           </a:p>
         </p:txBody>
@@ -994,6 +997,122 @@
           <a:lstStyle/>
           <a:p>
             <a:r>
+              <a:t>Numbers from the build run (evidence/04_readings_summary.md, 01_pipeline_run.md, 07_gateway.md). Still to model with the customer: hours of manual rounds removed per site x loaded cost, and vendor cost per image avoided.</a:t>
+            </a:r>
+          </a:p>
+        </p:txBody>
+      </p:sp>
+    </p:spTree>
+  </p:cSld>
+  <p:clrMapOvr>
+    <a:masterClrMapping/>
+  </p:clrMapOvr>
+</p:notes>
+</file>
+
+<file path=ppt/notesSlides/notesSlide6.xml><?xml version="1.0" encoding="utf-8"?>
+<p:notes xmlns:a="http://schemas.openxmlformats.org/drawingml/2006/main" xmlns:p="http://schemas.openxmlformats.org/presentationml/2006/main" xmlns:r="http://schemas.openxmlformats.org/officeDocument/2006/relationships">
+  <p:cSld>
+    <p:spTree>
+      <p:nvGrpSpPr>
+        <p:cNvPr id="1" name=""/>
+        <p:cNvGrpSpPr/>
+        <p:nvPr/>
+      </p:nvGrpSpPr>
+      <p:grpSpPr>
+        <a:xfrm>
+          <a:off x="0" y="0"/>
+          <a:ext cx="0" cy="0"/>
+          <a:chOff x="0" y="0"/>
+          <a:chExt cx="0" cy="0"/>
+        </a:xfrm>
+      </p:grpSpPr>
+      <p:sp>
+        <p:nvSpPr>
+          <p:cNvPr id="2" name="Slide Image Placeholder 1"/>
+          <p:cNvSpPr>
+            <a:spLocks noGrp="1"/>
+          </p:cNvSpPr>
+          <p:nvPr>
+            <p:ph type="sldImg" idx="2"/>
+          </p:nvPr>
+        </p:nvSpPr>
+        <p:spPr/>
+      </p:sp>
+      <p:sp>
+        <p:nvSpPr>
+          <p:cNvPr id="3" name="Notes Placeholder 2"/>
+          <p:cNvSpPr>
+            <a:spLocks noGrp="1"/>
+          </p:cNvSpPr>
+          <p:nvPr>
+            <p:ph type="body" idx="1"/>
+          </p:nvPr>
+        </p:nvSpPr>
+        <p:spPr/>
+        <p:txBody>
+          <a:bodyPr/>
+          <a:lstStyle/>
+          <a:p>
+            <a:r>
+              <a:t>Frame value for both personas the AI roleplay will play: the business stakeholder and the technical/domain stakeholder.</a:t>
+            </a:r>
+          </a:p>
+        </p:txBody>
+      </p:sp>
+    </p:spTree>
+  </p:cSld>
+  <p:clrMapOvr>
+    <a:masterClrMapping/>
+  </p:clrMapOvr>
+</p:notes>
+</file>
+
+<file path=ppt/notesSlides/notesSlide7.xml><?xml version="1.0" encoding="utf-8"?>
+<p:notes xmlns:a="http://schemas.openxmlformats.org/drawingml/2006/main" xmlns:p="http://schemas.openxmlformats.org/presentationml/2006/main" xmlns:r="http://schemas.openxmlformats.org/officeDocument/2006/relationships">
+  <p:cSld>
+    <p:spTree>
+      <p:nvGrpSpPr>
+        <p:cNvPr id="1" name=""/>
+        <p:cNvGrpSpPr/>
+        <p:nvPr/>
+      </p:nvGrpSpPr>
+      <p:grpSpPr>
+        <a:xfrm>
+          <a:off x="0" y="0"/>
+          <a:ext cx="0" cy="0"/>
+          <a:chOff x="0" y="0"/>
+          <a:chExt cx="0" cy="0"/>
+        </a:xfrm>
+      </p:grpSpPr>
+      <p:sp>
+        <p:nvSpPr>
+          <p:cNvPr id="2" name="Slide Image Placeholder 1"/>
+          <p:cNvSpPr>
+            <a:spLocks noGrp="1"/>
+          </p:cNvSpPr>
+          <p:nvPr>
+            <p:ph type="sldImg" idx="2"/>
+          </p:nvPr>
+        </p:nvSpPr>
+        <p:spPr/>
+      </p:sp>
+      <p:sp>
+        <p:nvSpPr>
+          <p:cNvPr id="3" name="Notes Placeholder 2"/>
+          <p:cNvSpPr>
+            <a:spLocks noGrp="1"/>
+          </p:cNvSpPr>
+          <p:nvPr>
+            <p:ph type="body" idx="1"/>
+          </p:nvPr>
+        </p:nvSpPr>
+        <p:spPr/>
+        <p:txBody>
+          <a:bodyPr/>
+          <a:lstStyle/>
+          <a:p>
+            <a:r>
               <a:t>Walk left to right: land, read, refine, serve, review, ask. Point out the closed loop (dashed arrow) and the Unity Catalog band under everything.</a:t>
             </a:r>
           </a:p>
@@ -1007,7 +1126,7 @@
 </p:notes>
 </file>
 
-<file path=ppt/notesSlides/notesSlide6.xml><?xml version="1.0" encoding="utf-8"?>
+<file path=ppt/notesSlides/notesSlide8.xml><?xml version="1.0" encoding="utf-8"?>
 <p:notes xmlns:a="http://schemas.openxmlformats.org/drawingml/2006/main" xmlns:p="http://schemas.openxmlformats.org/presentationml/2006/main" xmlns:r="http://schemas.openxmlformats.org/officeDocument/2006/relationships">
   <p:cSld>
     <p:spTree>
@@ -17155,7 +17274,7 @@
           <a:lstStyle/>
           <a:p>
             <a:r>
-              <a:t>Pressure Gauge Reader</a:t>
+              <a:t>Northbay Energy Gauge Reader</a:t>
             </a:r>
           </a:p>
         </p:txBody>
@@ -17176,7 +17295,7 @@
           <a:lstStyle/>
           <a:p>
             <a:r>
-              <a:t>AI-assisted gauge reading for refinery operator rounds</a:t>
+              <a:t>Robot inspection rounds, read by AI, checked by people</a:t>
             </a:r>
           </a:p>
         </p:txBody>
@@ -17197,7 +17316,7 @@
           <a:lstStyle/>
           <a:p>
             <a:r>
-              <a:t>Refinery operator rounds  |  October 2026</a:t>
+              <a:t>Refinery and terminal  |  October 2026</a:t>
             </a:r>
           </a:p>
         </p:txBody>
@@ -17211,6 +17330,486 @@
 </file>
 
 <file path=ppt/slides/slide10.xml><?xml version="1.0" encoding="utf-8"?>
+<p:sld xmlns:a="http://schemas.openxmlformats.org/drawingml/2006/main" xmlns:p="http://schemas.openxmlformats.org/presentationml/2006/main" xmlns:r="http://schemas.openxmlformats.org/officeDocument/2006/relationships">
+  <p:cSld>
+    <p:spTree>
+      <p:nvGrpSpPr>
+        <p:cNvPr id="1" name=""/>
+        <p:cNvGrpSpPr/>
+        <p:nvPr/>
+      </p:nvGrpSpPr>
+      <p:grpSpPr/>
+      <p:sp>
+        <p:nvSpPr>
+          <p:cNvPr id="2" name="Title 1"/>
+          <p:cNvSpPr>
+            <a:spLocks noGrp="1"/>
+          </p:cNvSpPr>
+          <p:nvPr>
+            <p:ph type="title"/>
+          </p:nvPr>
+        </p:nvSpPr>
+        <p:spPr/>
+        <p:txBody>
+          <a:bodyPr/>
+          <a:lstStyle/>
+          <a:p>
+            <a:r>
+              <a:t>Governed AI with a human in the loop</a:t>
+            </a:r>
+          </a:p>
+        </p:txBody>
+      </p:sp>
+      <p:sp>
+        <p:nvSpPr>
+          <p:cNvPr id="3" name="Text Placeholder 2"/>
+          <p:cNvSpPr>
+            <a:spLocks noGrp="1"/>
+          </p:cNvSpPr>
+          <p:nvPr>
+            <p:ph type="body" idx="1"/>
+          </p:nvPr>
+        </p:nvSpPr>
+        <p:spPr/>
+        <p:txBody>
+          <a:bodyPr/>
+          <a:lstStyle/>
+          <a:p>
+            <a:r>
+              <a:t>Confidence below 70%, unreadable dials and unexpectedly high readings always go to a reviewer</a:t>
+            </a:r>
+          </a:p>
+          <a:p>
+            <a:r>
+              <a:t>Decisions are appended, never overwritten</a:t>
+            </a:r>
+          </a:p>
+          <a:p>
+            <a:r>
+              <a:t>Human correction rate tracked as live accuracy</a:t>
+            </a:r>
+          </a:p>
+        </p:txBody>
+      </p:sp>
+      <p:sp>
+        <p:nvSpPr>
+          <p:cNvPr id="4" name="Text Placeholder 3"/>
+          <p:cNvSpPr>
+            <a:spLocks noGrp="1"/>
+          </p:cNvSpPr>
+          <p:nvPr>
+            <p:ph type="body" idx="2"/>
+          </p:nvPr>
+        </p:nvSpPr>
+        <p:spPr/>
+        <p:txBody>
+          <a:bodyPr/>
+          <a:lstStyle/>
+          <a:p>
+            <a:r>
+              <a:t>Analysts see the gold table only; the app reads images read-only</a:t>
+            </a:r>
+          </a:p>
+          <a:p>
+            <a:r>
+              <a:t>Lineage from raw image to the answer in Genie</a:t>
+            </a:r>
+          </a:p>
+          <a:p>
+            <a:r>
+              <a:t>Genie runs with the user's own permissions</a:t>
+            </a:r>
+          </a:p>
+        </p:txBody>
+      </p:sp>
+      <p:sp>
+        <p:nvSpPr>
+          <p:cNvPr id="5" name="Text Placeholder 4"/>
+          <p:cNvSpPr>
+            <a:spLocks noGrp="1"/>
+          </p:cNvSpPr>
+          <p:nvPr>
+            <p:ph type="body" idx="3"/>
+          </p:nvPr>
+        </p:nvSpPr>
+        <p:spPr/>
+        <p:txBody>
+          <a:bodyPr/>
+          <a:lstStyle/>
+          <a:p>
+            <a:r>
+              <a:t>Every model call attributed: requester, tokens, status</a:t>
+            </a:r>
+          </a:p>
+          <a:p>
+            <a:r>
+              <a:t>Cost per reading shown in the app (~$0.04 at list price)</a:t>
+            </a:r>
+          </a:p>
+          <a:p>
+            <a:r>
+              <a:t>Model access governed by UC EXECUTE; swap models without pipeline changes</a:t>
+            </a:r>
+          </a:p>
+        </p:txBody>
+      </p:sp>
+      <p:sp>
+        <p:nvSpPr>
+          <p:cNvPr id="6" name="Subtitle 5"/>
+          <p:cNvSpPr>
+            <a:spLocks noGrp="1"/>
+          </p:cNvSpPr>
+          <p:nvPr>
+            <p:ph type="subTitle" idx="4"/>
+          </p:nvPr>
+        </p:nvSpPr>
+        <p:spPr/>
+        <p:txBody>
+          <a:bodyPr/>
+          <a:lstStyle/>
+          <a:p>
+            <a:r>
+              <a:t>Human in the loop</a:t>
+            </a:r>
+          </a:p>
+        </p:txBody>
+      </p:sp>
+      <p:sp>
+        <p:nvSpPr>
+          <p:cNvPr id="7" name="Subtitle 6"/>
+          <p:cNvSpPr>
+            <a:spLocks noGrp="1"/>
+          </p:cNvSpPr>
+          <p:nvPr>
+            <p:ph type="subTitle" idx="5"/>
+          </p:nvPr>
+        </p:nvSpPr>
+        <p:spPr/>
+        <p:txBody>
+          <a:bodyPr/>
+          <a:lstStyle/>
+          <a:p>
+            <a:r>
+              <a:t>Unity Catalog</a:t>
+            </a:r>
+          </a:p>
+        </p:txBody>
+      </p:sp>
+      <p:sp>
+        <p:nvSpPr>
+          <p:cNvPr id="8" name="Subtitle 7"/>
+          <p:cNvSpPr>
+            <a:spLocks noGrp="1"/>
+          </p:cNvSpPr>
+          <p:nvPr>
+            <p:ph type="subTitle" idx="6"/>
+          </p:nvPr>
+        </p:nvSpPr>
+        <p:spPr/>
+        <p:txBody>
+          <a:bodyPr/>
+          <a:lstStyle/>
+          <a:p>
+            <a:r>
+              <a:t>Unity AI Gateway</a:t>
+            </a:r>
+          </a:p>
+        </p:txBody>
+      </p:sp>
+      <p:sp>
+        <p:nvSpPr>
+          <p:cNvPr id="9" name="Text Placeholder 8"/>
+          <p:cNvSpPr>
+            <a:spLocks noGrp="1"/>
+          </p:cNvSpPr>
+          <p:nvPr>
+            <p:ph type="body" idx="7"/>
+          </p:nvPr>
+        </p:nvSpPr>
+        <p:spPr/>
+        <p:txBody>
+          <a:bodyPr/>
+          <a:lstStyle/>
+          <a:p>
+            <a:r>
+              <a:t>AI reads, people decide where it matters, the platform keeps the record</a:t>
+            </a:r>
+          </a:p>
+        </p:txBody>
+      </p:sp>
+    </p:spTree>
+  </p:cSld>
+  <p:clrMapOvr>
+    <a:masterClrMapping/>
+  </p:clrMapOvr>
+</p:sld>
+</file>
+
+<file path=ppt/slides/slide11.xml><?xml version="1.0" encoding="utf-8"?>
+<p:sld xmlns:a="http://schemas.openxmlformats.org/drawingml/2006/main" xmlns:p="http://schemas.openxmlformats.org/presentationml/2006/main" xmlns:r="http://schemas.openxmlformats.org/officeDocument/2006/relationships">
+  <p:cSld>
+    <p:spTree>
+      <p:nvGrpSpPr>
+        <p:cNvPr id="1" name=""/>
+        <p:cNvGrpSpPr/>
+        <p:nvPr/>
+      </p:nvGrpSpPr>
+      <p:grpSpPr/>
+      <p:sp>
+        <p:nvSpPr>
+          <p:cNvPr id="2" name="Title 1"/>
+          <p:cNvSpPr>
+            <a:spLocks noGrp="1"/>
+          </p:cNvSpPr>
+          <p:nvPr>
+            <p:ph type="title"/>
+          </p:nvPr>
+        </p:nvSpPr>
+        <p:spPr/>
+        <p:txBody>
+          <a:bodyPr/>
+          <a:lstStyle/>
+          <a:p>
+            <a:r>
+              <a:t>Decisions and trade-offs</a:t>
+            </a:r>
+          </a:p>
+        </p:txBody>
+      </p:sp>
+      <p:sp>
+        <p:nvSpPr>
+          <p:cNvPr id="3" name="Text Placeholder 2"/>
+          <p:cNvSpPr>
+            <a:spLocks noGrp="1"/>
+          </p:cNvSpPr>
+          <p:nvPr>
+            <p:ph type="body" idx="1"/>
+          </p:nvPr>
+        </p:nvSpPr>
+        <p:spPr/>
+        <p:txBody>
+          <a:bodyPr/>
+          <a:lstStyle/>
+          <a:p>
+            <a:r>
+              <a:rPr sz="1700"/>
+              <a:t>Foundation vision model via ai_query, not a custom CNN: no labelled data or training; confidence-based review covers the gaps</a:t>
+            </a:r>
+          </a:p>
+          <a:p>
+            <a:r>
+              <a:rPr sz="1700"/>
+              <a:t>Model called inside the streaming table: each image read and billed once; reviewed readings never change on refresh</a:t>
+            </a:r>
+          </a:p>
+          <a:p>
+            <a:r>
+              <a:rPr sz="1700"/>
+              <a:t>Lakebase for the review step: low-latency transactional writes; decisions return to Delta via Lakehouse Sync</a:t>
+            </a:r>
+          </a:p>
+          <a:p>
+            <a:r>
+              <a:rPr sz="1700"/>
+              <a:t>Snapshot sync for serving: gold is a materialized view; at ~120 images/day a snapshot takes seconds</a:t>
+            </a:r>
+          </a:p>
+          <a:p>
+            <a:r>
+              <a:rPr sz="1700"/>
+              <a:t>“Unexpectedly high” = above the gauge's operating limit (default 75% of full scale), so Genie never invents thresholds</a:t>
+            </a:r>
+          </a:p>
+          <a:p>
+            <a:r>
+              <a:rPr sz="1700"/>
+              <a:t>GPT-5.5 chosen after testing 15 vision models: best accuracy among batch-capable models, with a confidence score that separates right from wrong</a:t>
+            </a:r>
+          </a:p>
+        </p:txBody>
+      </p:sp>
+      <p:sp>
+        <p:nvSpPr>
+          <p:cNvPr id="4" name="Text Placeholder 3"/>
+          <p:cNvSpPr>
+            <a:spLocks noGrp="1"/>
+          </p:cNvSpPr>
+          <p:nvPr>
+            <p:ph type="body" idx="2"/>
+          </p:nvPr>
+        </p:nvSpPr>
+        <p:spPr/>
+        <p:txBody>
+          <a:bodyPr/>
+          <a:lstStyle/>
+          <a:p>
+            <a:r>
+              <a:t>Why this approach and not another</a:t>
+            </a:r>
+          </a:p>
+        </p:txBody>
+      </p:sp>
+    </p:spTree>
+  </p:cSld>
+  <p:clrMapOvr>
+    <a:masterClrMapping/>
+  </p:clrMapOvr>
+</p:sld>
+</file>
+
+<file path=ppt/slides/slide12.xml><?xml version="1.0" encoding="utf-8"?>
+<p:sld xmlns:a="http://schemas.openxmlformats.org/drawingml/2006/main" xmlns:p="http://schemas.openxmlformats.org/presentationml/2006/main" xmlns:r="http://schemas.openxmlformats.org/officeDocument/2006/relationships">
+  <p:cSld>
+    <p:spTree>
+      <p:nvGrpSpPr>
+        <p:cNvPr id="1" name=""/>
+        <p:cNvGrpSpPr/>
+        <p:nvPr/>
+      </p:nvGrpSpPr>
+      <p:grpSpPr/>
+      <p:sp>
+        <p:nvSpPr>
+          <p:cNvPr id="2" name="Title 1"/>
+          <p:cNvSpPr>
+            <a:spLocks noGrp="1"/>
+          </p:cNvSpPr>
+          <p:nvPr>
+            <p:ph type="title"/>
+          </p:nvPr>
+        </p:nvSpPr>
+        <p:spPr/>
+        <p:txBody>
+          <a:bodyPr/>
+          <a:lstStyle/>
+          <a:p>
+            <a:r>
+              <a:t>Path to production</a:t>
+            </a:r>
+          </a:p>
+        </p:txBody>
+      </p:sp>
+      <p:sp>
+        <p:nvSpPr>
+          <p:cNvPr id="3" name="Text Placeholder 2"/>
+          <p:cNvSpPr>
+            <a:spLocks noGrp="1"/>
+          </p:cNvSpPr>
+          <p:nvPr>
+            <p:ph type="body" idx="1"/>
+          </p:nvPr>
+        </p:nvSpPr>
+        <p:spPr/>
+        <p:txBody>
+          <a:bodyPr/>
+          <a:lstStyle/>
+          <a:p>
+            <a:r>
+              <a:rPr sz="1600"/>
+              <a:t>Connect the robot fleet's image export to the raw volume (file-arrival trigger in place)</a:t>
+            </a:r>
+          </a:p>
+          <a:p>
+            <a:r>
+              <a:rPr sz="1600"/>
+              <a:t>Load real gauge tags and operating limits from the asset register</a:t>
+            </a:r>
+          </a:p>
+          <a:p>
+            <a:r>
+              <a:rPr sz="1600"/>
+              <a:t>Alert on unexpectedly high readings into the maintenance work-order system</a:t>
+            </a:r>
+          </a:p>
+          <a:p>
+            <a:r>
+              <a:rPr sz="1600"/>
+              <a:t>Extend the same pipeline to condition findings (rust, leaks) and per-gauge trends across rounds</a:t>
+            </a:r>
+          </a:p>
+          <a:p>
+            <a:r>
+              <a:rPr sz="1600"/>
+              <a:t>Promote with Declarative Automation Bundles (dev → prod) and named reviewer / analyst groups</a:t>
+            </a:r>
+          </a:p>
+        </p:txBody>
+      </p:sp>
+      <p:sp>
+        <p:nvSpPr>
+          <p:cNvPr id="4" name="Text Placeholder 3"/>
+          <p:cNvSpPr>
+            <a:spLocks noGrp="1"/>
+          </p:cNvSpPr>
+          <p:nvPr>
+            <p:ph type="body" idx="2"/>
+          </p:nvPr>
+        </p:nvSpPr>
+        <p:spPr/>
+        <p:txBody>
+          <a:bodyPr/>
+          <a:lstStyle/>
+          <a:p>
+            <a:r>
+              <a:rPr sz="1600"/>
+              <a:t>Pilot success criteria</a:t>
+            </a:r>
+          </a:p>
+          <a:p>
+            <a:r>
+              <a:rPr sz="1600"/>
+              <a:t>One site, [TBD] weeks</a:t>
+            </a:r>
+          </a:p>
+          <a:p>
+            <a:r>
+              <a:rPr sz="1600"/>
+              <a:t>Human correction rate below [TBD]%</a:t>
+            </a:r>
+          </a:p>
+          <a:p>
+            <a:r>
+              <a:rPr sz="1600"/>
+              <a:t>[TBD] hours of manual rounds removed</a:t>
+            </a:r>
+          </a:p>
+          <a:p>
+            <a:r>
+              <a:rPr sz="1600"/>
+              <a:t>Every reading traceable from photo to answer</a:t>
+            </a:r>
+          </a:p>
+        </p:txBody>
+      </p:sp>
+      <p:sp>
+        <p:nvSpPr>
+          <p:cNvPr id="5" name="Text Placeholder 4"/>
+          <p:cNvSpPr>
+            <a:spLocks noGrp="1"/>
+          </p:cNvSpPr>
+          <p:nvPr>
+            <p:ph type="body" idx="3"/>
+          </p:nvPr>
+        </p:nvSpPr>
+        <p:spPr/>
+        <p:txBody>
+          <a:bodyPr/>
+          <a:lstStyle/>
+          <a:p>
+            <a:r>
+              <a:t>From one demo round to a site pilot</a:t>
+            </a:r>
+          </a:p>
+        </p:txBody>
+      </p:sp>
+    </p:spTree>
+  </p:cSld>
+  <p:clrMapOvr>
+    <a:masterClrMapping/>
+  </p:clrMapOvr>
+</p:sld>
+</file>
+
+<file path=ppt/slides/slide13.xml><?xml version="1.0" encoding="utf-8"?>
 <p:sld xmlns:a="http://schemas.openxmlformats.org/drawingml/2006/main" xmlns:p="http://schemas.openxmlformats.org/presentationml/2006/main" xmlns:r="http://schemas.openxmlformats.org/officeDocument/2006/relationships">
   <p:cSld>
     <p:spTree>
@@ -17335,6 +17934,876 @@
           <a:lstStyle/>
           <a:p>
             <a:r>
+              <a:t>Why Northbay needs this</a:t>
+            </a:r>
+          </a:p>
+        </p:txBody>
+      </p:sp>
+      <p:sp>
+        <p:nvSpPr>
+          <p:cNvPr id="3" name="Text Placeholder 2"/>
+          <p:cNvSpPr>
+            <a:spLocks noGrp="1"/>
+          </p:cNvSpPr>
+          <p:nvPr>
+            <p:ph type="body" idx="1"/>
+          </p:nvPr>
+        </p:nvSpPr>
+        <p:spPr/>
+        <p:txBody>
+          <a:bodyPr/>
+          <a:lstStyle/>
+          <a:p>
+            <a:r>
+              <a:rPr sz="1500"/>
+              <a:t>The vast majority of plant gauges are still analog¹</a:t>
+            </a:r>
+          </a:p>
+          <a:p>
+            <a:r>
+              <a:rPr sz="1500"/>
+              <a:t>Swapping each for a transmitter means hot work, cabling and hazardous-area certification</a:t>
+            </a:r>
+          </a:p>
+          <a:p>
+            <a:r>
+              <a:rPr sz="1500"/>
+              <a:t>So the reading still has to come from a person, or a photo</a:t>
+            </a:r>
+          </a:p>
+        </p:txBody>
+      </p:sp>
+      <p:sp>
+        <p:nvSpPr>
+          <p:cNvPr id="4" name="Text Placeholder 3"/>
+          <p:cNvSpPr>
+            <a:spLocks noGrp="1"/>
+          </p:cNvSpPr>
+          <p:nvPr>
+            <p:ph type="body" idx="2"/>
+          </p:nvPr>
+        </p:nvSpPr>
+        <p:spPr/>
+        <p:txBody>
+          <a:bodyPr/>
+          <a:lstStyle/>
+          <a:p>
+            <a:r>
+              <a:rPr sz="1500"/>
+              <a:t>Rounds produce thousands of photos a month</a:t>
+            </a:r>
+          </a:p>
+          <a:p>
+            <a:r>
+              <a:rPr sz="1500"/>
+              <a:t>Glare, dirt, rain and steep angles defeat simple vision models¹</a:t>
+            </a:r>
+          </a:p>
+          <a:p>
+            <a:r>
+              <a:rPr sz="1500"/>
+              <a:t>Third-party readings still get re-checked by hand, outside the data platform</a:t>
+            </a:r>
+          </a:p>
+        </p:txBody>
+      </p:sp>
+      <p:sp>
+        <p:nvSpPr>
+          <p:cNvPr id="5" name="Text Placeholder 4"/>
+          <p:cNvSpPr>
+            <a:spLocks noGrp="1"/>
+          </p:cNvSpPr>
+          <p:nvPr>
+            <p:ph type="body" idx="3"/>
+          </p:nvPr>
+        </p:nvSpPr>
+        <p:spPr/>
+        <p:txBody>
+          <a:bodyPr/>
+          <a:lstStyle/>
+          <a:p>
+            <a:r>
+              <a:rPr sz="1500"/>
+              <a:t>An out-of-range pressure found at the next manual round is a missed early warning</a:t>
+            </a:r>
+          </a:p>
+          <a:p>
+            <a:r>
+              <a:rPr sz="1500"/>
+              <a:t>Unplanned downtime costs the world's 500 largest companies ~$1.4tn a year, 11% of revenue²</a:t>
+            </a:r>
+          </a:p>
+        </p:txBody>
+      </p:sp>
+      <p:sp>
+        <p:nvSpPr>
+          <p:cNvPr id="6" name="Subtitle 5"/>
+          <p:cNvSpPr>
+            <a:spLocks noGrp="1"/>
+          </p:cNvSpPr>
+          <p:nvPr>
+            <p:ph type="subTitle" idx="4"/>
+          </p:nvPr>
+        </p:nvSpPr>
+        <p:spPr/>
+        <p:txBody>
+          <a:bodyPr/>
+          <a:lstStyle/>
+          <a:p>
+            <a:r>
+              <a:t>Analog gauges are here to stay</a:t>
+            </a:r>
+          </a:p>
+        </p:txBody>
+      </p:sp>
+      <p:sp>
+        <p:nvSpPr>
+          <p:cNvPr id="7" name="Subtitle 6"/>
+          <p:cNvSpPr>
+            <a:spLocks noGrp="1"/>
+          </p:cNvSpPr>
+          <p:nvPr>
+            <p:ph type="subTitle" idx="5"/>
+          </p:nvPr>
+        </p:nvSpPr>
+        <p:spPr/>
+        <p:txBody>
+          <a:bodyPr/>
+          <a:lstStyle/>
+          <a:p>
+            <a:r>
+              <a:t>A photo is not a reading</a:t>
+            </a:r>
+          </a:p>
+        </p:txBody>
+      </p:sp>
+      <p:sp>
+        <p:nvSpPr>
+          <p:cNvPr id="8" name="Subtitle 7"/>
+          <p:cNvSpPr>
+            <a:spLocks noGrp="1"/>
+          </p:cNvSpPr>
+          <p:nvPr>
+            <p:ph type="subTitle" idx="6"/>
+          </p:nvPr>
+        </p:nvSpPr>
+        <p:spPr/>
+        <p:txBody>
+          <a:bodyPr/>
+          <a:lstStyle/>
+          <a:p>
+            <a:r>
+              <a:t>Late readings cost money</a:t>
+            </a:r>
+          </a:p>
+        </p:txBody>
+      </p:sp>
+      <p:sp>
+        <p:nvSpPr>
+          <p:cNvPr id="9" name="Text Placeholder 8"/>
+          <p:cNvSpPr>
+            <a:spLocks noGrp="1"/>
+          </p:cNvSpPr>
+          <p:nvPr>
+            <p:ph type="body" idx="7"/>
+          </p:nvPr>
+        </p:nvSpPr>
+        <p:spPr/>
+        <p:txBody>
+          <a:bodyPr/>
+          <a:lstStyle/>
+          <a:p>
+            <a:r>
+              <a:t>Robots photograph every gauge — trusted readings are the bottleneck</a:t>
+            </a:r>
+          </a:p>
+        </p:txBody>
+      </p:sp>
+      <p:sp>
+        <p:nvSpPr>
+          <p:cNvPr id="10" name="TextBox 9"/>
+          <p:cNvSpPr txBox="1"/>
+          <p:nvPr/>
+        </p:nvSpPr>
+        <p:spPr>
+          <a:xfrm>
+            <a:off x="758952" y="6199632"/>
+            <a:ext cx="10661904" cy="274320"/>
+          </a:xfrm>
+          <a:prstGeom prst="rect">
+            <a:avLst/>
+          </a:prstGeom>
+          <a:noFill/>
+        </p:spPr>
+        <p:txBody>
+          <a:bodyPr wrap="square" anchor="t" lIns="45720" rIns="45720">
+            <a:spAutoFit/>
+          </a:bodyPr>
+          <a:lstStyle/>
+          <a:p>
+            <a:pPr algn="l"/>
+            <a:r>
+              <a:rPr sz="900" b="0">
+                <a:solidFill>
+                  <a:srgbClr val="5F6B70"/>
+                </a:solidFill>
+                <a:latin typeface="DM Sans"/>
+              </a:rPr>
+              <a:t>¹ Reitsma et al., “Under pressure: learning-based analog gauge reading in the wild”, ETH Zurich, ICRA 2024.   ² Siemens, The True Cost of Downtime 2024.</a:t>
+            </a:r>
+          </a:p>
+        </p:txBody>
+      </p:sp>
+    </p:spTree>
+  </p:cSld>
+  <p:clrMapOvr>
+    <a:masterClrMapping/>
+  </p:clrMapOvr>
+</p:sld>
+</file>
+
+<file path=ppt/slides/slide4.xml><?xml version="1.0" encoding="utf-8"?>
+<p:sld xmlns:a="http://schemas.openxmlformats.org/drawingml/2006/main" xmlns:p="http://schemas.openxmlformats.org/presentationml/2006/main" xmlns:r="http://schemas.openxmlformats.org/officeDocument/2006/relationships">
+  <p:cSld>
+    <p:spTree>
+      <p:nvGrpSpPr>
+        <p:cNvPr id="1" name=""/>
+        <p:cNvGrpSpPr/>
+        <p:nvPr/>
+      </p:nvGrpSpPr>
+      <p:grpSpPr/>
+      <p:sp>
+        <p:nvSpPr>
+          <p:cNvPr id="2" name="Title 1"/>
+          <p:cNvSpPr>
+            <a:spLocks noGrp="1"/>
+          </p:cNvSpPr>
+          <p:nvPr>
+            <p:ph type="title"/>
+          </p:nvPr>
+        </p:nvSpPr>
+        <p:spPr/>
+        <p:txBody>
+          <a:bodyPr/>
+          <a:lstStyle/>
+          <a:p>
+            <a:r>
+              <a:t>What we hear from energy operators</a:t>
+            </a:r>
+          </a:p>
+        </p:txBody>
+      </p:sp>
+      <p:sp>
+        <p:nvSpPr>
+          <p:cNvPr id="4" name="Text Placeholder 3"/>
+          <p:cNvSpPr>
+            <a:spLocks noGrp="1"/>
+          </p:cNvSpPr>
+          <p:nvPr>
+            <p:ph type="body" idx="2"/>
+          </p:nvPr>
+        </p:nvSpPr>
+        <p:spPr/>
+        <p:txBody>
+          <a:bodyPr/>
+          <a:lstStyle/>
+          <a:p>
+            <a:r>
+              <a:t>Patterns from robot inspection programmes, and our answer to each</a:t>
+            </a:r>
+          </a:p>
+        </p:txBody>
+      </p:sp>
+      <p:graphicFrame>
+        <p:nvGraphicFramePr>
+          <p:cNvPr id="5" name="Table 4"/>
+          <p:cNvGraphicFramePr>
+            <a:graphicFrameLocks noGrp="1"/>
+          </p:cNvGraphicFramePr>
+          <p:nvPr/>
+        </p:nvGraphicFramePr>
+        <p:xfrm>
+          <a:off x="761825" y="1760233"/>
+          <a:ext cx="10659300" cy="4023360"/>
+        </p:xfrm>
+        <a:graphic>
+          <a:graphicData uri="http://schemas.openxmlformats.org/drawingml/2006/table">
+            <a:tbl>
+              <a:tblPr firstRow="1" bandRow="1">
+                <a:tableStyleId>{5C22544A-7EE6-4342-B048-85BDC9FD1C3A}</a:tableStyleId>
+              </a:tblPr>
+              <a:tblGrid>
+                <a:gridCol w="4903278"/>
+                <a:gridCol w="5756022"/>
+              </a:tblGrid>
+              <a:tr h="670560">
+                <a:tc>
+                  <a:txBody>
+                    <a:bodyPr wrap="square" anchor="ctr" lIns="45720" rIns="45720"/>
+                    <a:lstStyle/>
+                    <a:p>
+                      <a:pPr algn="l"/>
+                      <a:r>
+                        <a:rPr sz="1400" b="1">
+                          <a:solidFill>
+                            <a:srgbClr val="FFFFFF"/>
+                          </a:solidFill>
+                          <a:latin typeface="DM Sans"/>
+                        </a:rPr>
+                        <a:t>What operators tell us</a:t>
+                      </a:r>
+                    </a:p>
+                  </a:txBody>
+                  <a:tcPr>
+                    <a:solidFill>
+                      <a:srgbClr val="1B3037"/>
+                    </a:solidFill>
+                  </a:tcPr>
+                </a:tc>
+                <a:tc>
+                  <a:txBody>
+                    <a:bodyPr wrap="square" anchor="ctr" lIns="45720" rIns="45720"/>
+                    <a:lstStyle/>
+                    <a:p>
+                      <a:pPr algn="l"/>
+                      <a:r>
+                        <a:rPr sz="1400" b="1">
+                          <a:solidFill>
+                            <a:srgbClr val="FFFFFF"/>
+                          </a:solidFill>
+                          <a:latin typeface="DM Sans"/>
+                        </a:rPr>
+                        <a:t>How Northbay's Gauge Reader answers it</a:t>
+                      </a:r>
+                    </a:p>
+                  </a:txBody>
+                  <a:tcPr>
+                    <a:solidFill>
+                      <a:srgbClr val="1B3037"/>
+                    </a:solidFill>
+                  </a:tcPr>
+                </a:tc>
+              </a:tr>
+              <a:tr h="670560">
+                <a:tc>
+                  <a:txBody>
+                    <a:bodyPr wrap="square" anchor="ctr" lIns="45720" rIns="45720"/>
+                    <a:lstStyle/>
+                    <a:p>
+                      <a:pPr algn="l"/>
+                      <a:r>
+                        <a:rPr sz="1300" b="0" i="1">
+                          <a:solidFill>
+                            <a:srgbClr val="1B3037"/>
+                          </a:solidFill>
+                          <a:latin typeface="DM Sans"/>
+                        </a:rPr>
+                        <a:t>“Accuracy comes first — a wrong reading is worse than a late one.”</a:t>
+                      </a:r>
+                    </a:p>
+                  </a:txBody>
+                  <a:tcPr>
+                    <a:solidFill>
+                      <a:srgbClr val="F4F6F7"/>
+                    </a:solidFill>
+                  </a:tcPr>
+                </a:tc>
+                <a:tc>
+                  <a:txBody>
+                    <a:bodyPr wrap="square" anchor="ctr" lIns="45720" rIns="45720"/>
+                    <a:lstStyle/>
+                    <a:p>
+                      <a:pPr algn="l"/>
+                      <a:r>
+                        <a:rPr sz="1300" b="0" i="0">
+                          <a:solidFill>
+                            <a:srgbClr val="1B3037"/>
+                          </a:solidFill>
+                          <a:latin typeface="DM Sans"/>
+                        </a:rPr>
+                        <a:t>Every reading carries a confidence score; low-confidence, unreadable and unexpectedly high readings always go to a person</a:t>
+                      </a:r>
+                    </a:p>
+                  </a:txBody>
+                  <a:tcPr>
+                    <a:solidFill>
+                      <a:srgbClr val="F4F6F7"/>
+                    </a:solidFill>
+                  </a:tcPr>
+                </a:tc>
+              </a:tr>
+              <a:tr h="670560">
+                <a:tc>
+                  <a:txBody>
+                    <a:bodyPr wrap="square" anchor="ctr" lIns="45720" rIns="45720"/>
+                    <a:lstStyle/>
+                    <a:p>
+                      <a:pPr algn="l"/>
+                      <a:r>
+                        <a:rPr sz="1300" b="0" i="1">
+                          <a:solidFill>
+                            <a:srgbClr val="1B3037"/>
+                          </a:solidFill>
+                          <a:latin typeface="DM Sans"/>
+                        </a:rPr>
+                        <a:t>“We pay a vendor per image, and still check its readings by hand.”</a:t>
+                      </a:r>
+                    </a:p>
+                  </a:txBody>
+                  <a:tcPr>
+                    <a:solidFill>
+                      <a:srgbClr val="FFFFFF"/>
+                    </a:solidFill>
+                  </a:tcPr>
+                </a:tc>
+                <a:tc>
+                  <a:txBody>
+                    <a:bodyPr wrap="square" anchor="ctr" lIns="45720" rIns="45720"/>
+                    <a:lstStyle/>
+                    <a:p>
+                      <a:pPr algn="l"/>
+                      <a:r>
+                        <a:rPr sz="1300" b="0" i="0">
+                          <a:solidFill>
+                            <a:srgbClr val="1B3037"/>
+                          </a:solidFill>
+                          <a:latin typeface="DM Sans"/>
+                        </a:rPr>
+                        <a:t>Readings run inside the platform at a known cost per reading (~$0.04), with every correction audited</a:t>
+                      </a:r>
+                    </a:p>
+                  </a:txBody>
+                  <a:tcPr>
+                    <a:solidFill>
+                      <a:srgbClr val="FFFFFF"/>
+                    </a:solidFill>
+                  </a:tcPr>
+                </a:tc>
+              </a:tr>
+              <a:tr h="670560">
+                <a:tc>
+                  <a:txBody>
+                    <a:bodyPr wrap="square" anchor="ctr" lIns="45720" rIns="45720"/>
+                    <a:lstStyle/>
+                    <a:p>
+                      <a:pPr algn="l"/>
+                      <a:r>
+                        <a:rPr sz="1300" b="0" i="1">
+                          <a:solidFill>
+                            <a:srgbClr val="1B3037"/>
+                          </a:solidFill>
+                          <a:latin typeface="DM Sans"/>
+                        </a:rPr>
+                        <a:t>“Photos are taken in fog, rain and glare, on dirty dials.”</a:t>
+                      </a:r>
+                    </a:p>
+                  </a:txBody>
+                  <a:tcPr>
+                    <a:solidFill>
+                      <a:srgbClr val="F4F6F7"/>
+                    </a:solidFill>
+                  </a:tcPr>
+                </a:tc>
+                <a:tc>
+                  <a:txBody>
+                    <a:bodyPr wrap="square" anchor="ctr" lIns="45720" rIns="45720"/>
+                    <a:lstStyle/>
+                    <a:p>
+                      <a:pPr algn="l"/>
+                      <a:r>
+                        <a:rPr sz="1300" b="0" i="0">
+                          <a:solidFill>
+                            <a:srgbClr val="1B3037"/>
+                          </a:solidFill>
+                          <a:latin typeface="DM Sans"/>
+                        </a:rPr>
+                        <a:t>The model reports image issues (glare, blur, angle, dirt) so reviewers see why a reading was flagged</a:t>
+                      </a:r>
+                    </a:p>
+                  </a:txBody>
+                  <a:tcPr>
+                    <a:solidFill>
+                      <a:srgbClr val="F4F6F7"/>
+                    </a:solidFill>
+                  </a:tcPr>
+                </a:tc>
+              </a:tr>
+              <a:tr h="670560">
+                <a:tc>
+                  <a:txBody>
+                    <a:bodyPr wrap="square" anchor="ctr" lIns="45720" rIns="45720"/>
+                    <a:lstStyle/>
+                    <a:p>
+                      <a:pPr algn="l"/>
+                      <a:r>
+                        <a:rPr sz="1300" b="0" i="1">
+                          <a:solidFill>
+                            <a:srgbClr val="1B3037"/>
+                          </a:solidFill>
+                          <a:latin typeface="DM Sans"/>
+                        </a:rPr>
+                        <a:t>“We want to own the capability, not rent a black box.”</a:t>
+                      </a:r>
+                    </a:p>
+                  </a:txBody>
+                  <a:tcPr>
+                    <a:solidFill>
+                      <a:srgbClr val="FFFFFF"/>
+                    </a:solidFill>
+                  </a:tcPr>
+                </a:tc>
+                <a:tc>
+                  <a:txBody>
+                    <a:bodyPr wrap="square" anchor="ctr" lIns="45720" rIns="45720"/>
+                    <a:lstStyle/>
+                    <a:p>
+                      <a:pPr algn="l"/>
+                      <a:r>
+                        <a:rPr sz="1300" b="0" i="0">
+                          <a:solidFill>
+                            <a:srgbClr val="1B3037"/>
+                          </a:solidFill>
+                          <a:latin typeface="DM Sans"/>
+                        </a:rPr>
+                        <a:t>A governed foundation model in Unity Catalog: no training data, swap models through Unity AI Gateway</a:t>
+                      </a:r>
+                    </a:p>
+                  </a:txBody>
+                  <a:tcPr>
+                    <a:solidFill>
+                      <a:srgbClr val="FFFFFF"/>
+                    </a:solidFill>
+                  </a:tcPr>
+                </a:tc>
+              </a:tr>
+              <a:tr h="670560">
+                <a:tc>
+                  <a:txBody>
+                    <a:bodyPr wrap="square" anchor="ctr" lIns="45720" rIns="45720"/>
+                    <a:lstStyle/>
+                    <a:p>
+                      <a:pPr algn="l"/>
+                      <a:r>
+                        <a:rPr sz="1300" b="0" i="1">
+                          <a:solidFill>
+                            <a:srgbClr val="1B3037"/>
+                          </a:solidFill>
+                          <a:latin typeface="DM Sans"/>
+                        </a:rPr>
+                        <a:t>“Next: spot rust and leaks, and trends across rounds.”</a:t>
+                      </a:r>
+                    </a:p>
+                  </a:txBody>
+                  <a:tcPr>
+                    <a:solidFill>
+                      <a:srgbClr val="F4F6F7"/>
+                    </a:solidFill>
+                  </a:tcPr>
+                </a:tc>
+                <a:tc>
+                  <a:txBody>
+                    <a:bodyPr wrap="square" anchor="ctr" lIns="45720" rIns="45720"/>
+                    <a:lstStyle/>
+                    <a:p>
+                      <a:pPr algn="l"/>
+                      <a:r>
+                        <a:rPr sz="1300" b="0" i="0">
+                          <a:solidFill>
+                            <a:srgbClr val="1B3037"/>
+                          </a:solidFill>
+                          <a:latin typeface="DM Sans"/>
+                        </a:rPr>
+                        <a:t>The same pipeline extends to condition findings and per-gauge trends, feeding maintenance work orders</a:t>
+                      </a:r>
+                    </a:p>
+                  </a:txBody>
+                  <a:tcPr>
+                    <a:solidFill>
+                      <a:srgbClr val="F4F6F7"/>
+                    </a:solidFill>
+                  </a:tcPr>
+                </a:tc>
+              </a:tr>
+            </a:tbl>
+          </a:graphicData>
+        </a:graphic>
+      </p:graphicFrame>
+    </p:spTree>
+  </p:cSld>
+  <p:clrMapOvr>
+    <a:masterClrMapping/>
+  </p:clrMapOvr>
+</p:sld>
+</file>
+
+<file path=ppt/slides/slide5.xml><?xml version="1.0" encoding="utf-8"?>
+<p:sld xmlns:a="http://schemas.openxmlformats.org/drawingml/2006/main" xmlns:p="http://schemas.openxmlformats.org/presentationml/2006/main" xmlns:r="http://schemas.openxmlformats.org/officeDocument/2006/relationships">
+  <p:cSld>
+    <p:spTree>
+      <p:nvGrpSpPr>
+        <p:cNvPr id="1" name=""/>
+        <p:cNvGrpSpPr/>
+        <p:nvPr/>
+      </p:nvGrpSpPr>
+      <p:grpSpPr/>
+      <p:sp>
+        <p:nvSpPr>
+          <p:cNvPr id="2" name="Title 1"/>
+          <p:cNvSpPr>
+            <a:spLocks noGrp="1"/>
+          </p:cNvSpPr>
+          <p:nvPr>
+            <p:ph type="title"/>
+          </p:nvPr>
+        </p:nvSpPr>
+        <p:spPr/>
+        <p:txBody>
+          <a:bodyPr/>
+          <a:lstStyle/>
+          <a:p>
+            <a:r>
+              <a:t>Why now</a:t>
+            </a:r>
+          </a:p>
+        </p:txBody>
+      </p:sp>
+      <p:sp>
+        <p:nvSpPr>
+          <p:cNvPr id="3" name="Text Placeholder 2"/>
+          <p:cNvSpPr>
+            <a:spLocks noGrp="1"/>
+          </p:cNvSpPr>
+          <p:nvPr>
+            <p:ph type="body" idx="1"/>
+          </p:nvPr>
+        </p:nvSpPr>
+        <p:spPr/>
+        <p:txBody>
+          <a:bodyPr/>
+          <a:lstStyle/>
+          <a:p>
+            <a:r>
+              <a:rPr sz="1500"/>
+              <a:t>Legged robots and drones run routine rounds in hazardous areas</a:t>
+            </a:r>
+          </a:p>
+          <a:p>
+            <a:r>
+              <a:rPr sz="1500"/>
+              <a:t>Inspection robots already capture images at scale: 120,000+ inspections analysed a month by one vendor alone³</a:t>
+            </a:r>
+          </a:p>
+        </p:txBody>
+      </p:sp>
+      <p:sp>
+        <p:nvSpPr>
+          <p:cNvPr id="4" name="Text Placeholder 3"/>
+          <p:cNvSpPr>
+            <a:spLocks noGrp="1"/>
+          </p:cNvSpPr>
+          <p:nvPr>
+            <p:ph type="body" idx="2"/>
+          </p:nvPr>
+        </p:nvSpPr>
+        <p:spPr/>
+        <p:txBody>
+          <a:bodyPr/>
+          <a:lstStyle/>
+          <a:p>
+            <a:r>
+              <a:rPr sz="1500"/>
+              <a:t>Foundation vision models read a dial with no labelled data or training</a:t>
+            </a:r>
+          </a:p>
+          <a:p>
+            <a:r>
+              <a:rPr sz="1500"/>
+              <a:t>They also say how sure they are, so people only check the uncertain ones</a:t>
+            </a:r>
+          </a:p>
+        </p:txBody>
+      </p:sp>
+      <p:sp>
+        <p:nvSpPr>
+          <p:cNvPr id="5" name="Text Placeholder 4"/>
+          <p:cNvSpPr>
+            <a:spLocks noGrp="1"/>
+          </p:cNvSpPr>
+          <p:nvPr>
+            <p:ph type="body" idx="3"/>
+          </p:nvPr>
+        </p:nvSpPr>
+        <p:spPr/>
+        <p:txBody>
+          <a:bodyPr/>
+          <a:lstStyle/>
+          <a:p>
+            <a:r>
+              <a:rPr sz="1500"/>
+              <a:t>One governed platform from photo to answer: Lakeflow, Unity Catalog, Lakebase, Genie</a:t>
+            </a:r>
+          </a:p>
+          <a:p>
+            <a:r>
+              <a:rPr sz="1500"/>
+              <a:t>Every model call logged and costed: ~$0.04 per reading at list price</a:t>
+            </a:r>
+          </a:p>
+        </p:txBody>
+      </p:sp>
+      <p:sp>
+        <p:nvSpPr>
+          <p:cNvPr id="6" name="Subtitle 5"/>
+          <p:cNvSpPr>
+            <a:spLocks noGrp="1"/>
+          </p:cNvSpPr>
+          <p:nvPr>
+            <p:ph type="subTitle" idx="4"/>
+          </p:nvPr>
+        </p:nvSpPr>
+        <p:spPr/>
+        <p:txBody>
+          <a:bodyPr/>
+          <a:lstStyle/>
+          <a:p>
+            <a:r>
+              <a:t>Robots are already on site</a:t>
+            </a:r>
+          </a:p>
+        </p:txBody>
+      </p:sp>
+      <p:sp>
+        <p:nvSpPr>
+          <p:cNvPr id="7" name="Subtitle 6"/>
+          <p:cNvSpPr>
+            <a:spLocks noGrp="1"/>
+          </p:cNvSpPr>
+          <p:nvPr>
+            <p:ph type="subTitle" idx="5"/>
+          </p:nvPr>
+        </p:nvSpPr>
+        <p:spPr/>
+        <p:txBody>
+          <a:bodyPr/>
+          <a:lstStyle/>
+          <a:p>
+            <a:r>
+              <a:t>Vision models read dials</a:t>
+            </a:r>
+          </a:p>
+        </p:txBody>
+      </p:sp>
+      <p:sp>
+        <p:nvSpPr>
+          <p:cNvPr id="8" name="Subtitle 7"/>
+          <p:cNvSpPr>
+            <a:spLocks noGrp="1"/>
+          </p:cNvSpPr>
+          <p:nvPr>
+            <p:ph type="subTitle" idx="6"/>
+          </p:nvPr>
+        </p:nvSpPr>
+        <p:spPr/>
+        <p:txBody>
+          <a:bodyPr/>
+          <a:lstStyle/>
+          <a:p>
+            <a:r>
+              <a:t>Governed, at a known cost</a:t>
+            </a:r>
+          </a:p>
+        </p:txBody>
+      </p:sp>
+      <p:sp>
+        <p:nvSpPr>
+          <p:cNvPr id="9" name="Text Placeholder 8"/>
+          <p:cNvSpPr>
+            <a:spLocks noGrp="1"/>
+          </p:cNvSpPr>
+          <p:nvPr>
+            <p:ph type="body" idx="7"/>
+          </p:nvPr>
+        </p:nvSpPr>
+        <p:spPr/>
+        <p:txBody>
+          <a:bodyPr/>
+          <a:lstStyle/>
+          <a:p>
+            <a:r>
+              <a:t>The three pieces that were missing are now in place</a:t>
+            </a:r>
+          </a:p>
+        </p:txBody>
+      </p:sp>
+      <p:sp>
+        <p:nvSpPr>
+          <p:cNvPr id="10" name="TextBox 9"/>
+          <p:cNvSpPr txBox="1"/>
+          <p:nvPr/>
+        </p:nvSpPr>
+        <p:spPr>
+          <a:xfrm>
+            <a:off x="758952" y="6199632"/>
+            <a:ext cx="10661904" cy="274320"/>
+          </a:xfrm>
+          <a:prstGeom prst="rect">
+            <a:avLst/>
+          </a:prstGeom>
+          <a:noFill/>
+        </p:spPr>
+        <p:txBody>
+          <a:bodyPr wrap="square" anchor="t" lIns="45720" rIns="45720">
+            <a:spAutoFit/>
+          </a:bodyPr>
+          <a:lstStyle/>
+          <a:p>
+            <a:pPr algn="l"/>
+            <a:r>
+              <a:rPr sz="900" b="0">
+                <a:solidFill>
+                  <a:srgbClr val="5F6B70"/>
+                </a:solidFill>
+                <a:latin typeface="DM Sans"/>
+              </a:rPr>
+              <a:t>³ ANYbotics, anybotics.com (vendor-reported figure).   Cost per reading: build run, GPT-5.5 via Unity AI Gateway (evidence/07_gateway.md).</a:t>
+            </a:r>
+          </a:p>
+        </p:txBody>
+      </p:sp>
+    </p:spTree>
+  </p:cSld>
+  <p:clrMapOvr>
+    <a:masterClrMapping/>
+  </p:clrMapOvr>
+</p:sld>
+</file>
+
+<file path=ppt/slides/slide6.xml><?xml version="1.0" encoding="utf-8"?>
+<p:sld xmlns:a="http://schemas.openxmlformats.org/drawingml/2006/main" xmlns:p="http://schemas.openxmlformats.org/presentationml/2006/main" xmlns:r="http://schemas.openxmlformats.org/officeDocument/2006/relationships">
+  <p:cSld>
+    <p:spTree>
+      <p:nvGrpSpPr>
+        <p:cNvPr id="1" name=""/>
+        <p:cNvGrpSpPr/>
+        <p:nvPr/>
+      </p:nvGrpSpPr>
+      <p:grpSpPr/>
+      <p:sp>
+        <p:nvSpPr>
+          <p:cNvPr id="2" name="Title 1"/>
+          <p:cNvSpPr>
+            <a:spLocks noGrp="1"/>
+          </p:cNvSpPr>
+          <p:nvPr>
+            <p:ph type="title"/>
+          </p:nvPr>
+        </p:nvSpPr>
+        <p:spPr/>
+        <p:txBody>
+          <a:bodyPr/>
+          <a:lstStyle/>
+          <a:p>
+            <a:r>
               <a:t>What changes for operations</a:t>
             </a:r>
           </a:p>
@@ -17356,12 +18825,12 @@
           <a:lstStyle/>
           <a:p>
             <a:r>
-              <a:t>Manual gauge transcription removed per site</a:t>
+              <a:t>20 of 30 readings read and accepted by AI</a:t>
             </a:r>
           </a:p>
           <a:p>
             <a:r>
-              <a:t>Readings no longer outsourced to a third-party vendor</a:t>
+              <a:t>Reviewers check 10, not 30 — no manual transcription</a:t>
             </a:r>
           </a:p>
         </p:txBody>
@@ -17382,7 +18851,7 @@
           <a:lstStyle/>
           <a:p>
             <a:r>
-              <a:t>From robot photo to a trusted reading in the review app</a:t>
+              <a:t>One pipeline run read the whole round, each photo once</a:t>
             </a:r>
           </a:p>
           <a:p>
@@ -17408,12 +18877,12 @@
           <a:lstStyle/>
           <a:p>
             <a:r>
-              <a:t>Every low-confidence, unreadable or unexpectedly high reading goes to a human</a:t>
+              <a:t>AI cost at list price, every call attributed</a:t>
             </a:r>
           </a:p>
           <a:p>
             <a:r>
-              <a:t>Every correction audited</a:t>
+              <a:t>100% of uncertain or unexpectedly high readings checked by a person</a:t>
             </a:r>
           </a:p>
         </p:txBody>
@@ -17434,7 +18903,7 @@
           <a:lstStyle/>
           <a:p>
             <a:r>
-              <a:t>[TBD] hrs / week</a:t>
+              <a:t>67% need no one</a:t>
             </a:r>
           </a:p>
         </p:txBody>
@@ -17455,7 +18924,7 @@
           <a:lstStyle/>
           <a:p>
             <a:r>
-              <a:t>&lt; 5 minutes</a:t>
+              <a:t>&lt; 3 minutes</a:t>
             </a:r>
           </a:p>
         </p:txBody>
@@ -17476,7 +18945,7 @@
           <a:lstStyle/>
           <a:p>
             <a:r>
-              <a:t>100% checked</a:t>
+              <a:t>~$0.04 per reading</a:t>
             </a:r>
           </a:p>
         </p:txBody>
@@ -17497,7 +18966,7 @@
           <a:lstStyle/>
           <a:p>
             <a:r>
-              <a:t>Robots already photograph the gauges — now every reading is trusted</a:t>
+              <a:t>Measured on the build round: 30 gauges, 2 sites</a:t>
             </a:r>
           </a:p>
         </p:txBody>
@@ -17510,7 +18979,7 @@
 </p:sld>
 </file>
 
-<file path=ppt/slides/slide4.xml><?xml version="1.0" encoding="utf-8"?>
+<file path=ppt/slides/slide7.xml><?xml version="1.0" encoding="utf-8"?>
 <p:sld xmlns:a="http://schemas.openxmlformats.org/drawingml/2006/main" xmlns:p="http://schemas.openxmlformats.org/presentationml/2006/main" xmlns:r="http://schemas.openxmlformats.org/officeDocument/2006/relationships">
   <p:cSld>
     <p:spTree>
@@ -17557,16 +19026,19 @@
           <a:lstStyle/>
           <a:p>
             <a:r>
+              <a:rPr sz="1600"/>
               <a:t>Fewer people in hazardous areas for routine rounds: [TBD] exposure hours avoided per year</a:t>
             </a:r>
           </a:p>
           <a:p>
             <a:r>
-              <a:t>Vendor dependency removed: [TBD] cost per image today vs. pay-per-token on the platform</a:t>
+              <a:rPr sz="1600"/>
+              <a:t>Vendor dependency removed: ~$0.04 per reading on the platform vs. [TBD] per image today</a:t>
             </a:r>
           </a:p>
           <a:p>
             <a:r>
+              <a:rPr sz="1600"/>
               <a:t>Unexpectedly high pressures surfaced the same shift, not at the next manual round</a:t>
             </a:r>
           </a:p>
@@ -17588,16 +19060,19 @@
           <a:lstStyle/>
           <a:p>
             <a:r>
+              <a:rPr sz="1600"/>
               <a:t>One review queue, sorted by risk: low confidence, unreadable, unexpectedly high</a:t>
             </a:r>
           </a:p>
           <a:p>
             <a:r>
+              <a:rPr sz="1600"/>
               <a:t>Every correction audited (who, when, why) and fed back to the lakehouse</a:t>
             </a:r>
           </a:p>
           <a:p>
             <a:r>
+              <a:rPr sz="1600"/>
               <a:t>Ask in plain English: “Are any pressure readings unexpectedly high?”</a:t>
             </a:r>
           </a:p>
@@ -17674,7 +19149,7 @@
 </p:sld>
 </file>
 
-<file path=ppt/slides/slide5.xml><?xml version="1.0" encoding="utf-8"?>
+<file path=ppt/slides/slide8.xml><?xml version="1.0" encoding="utf-8"?>
 <p:sld xmlns:a="http://schemas.openxmlformats.org/drawingml/2006/main" xmlns:p="http://schemas.openxmlformats.org/presentationml/2006/main" xmlns:r="http://schemas.openxmlformats.org/officeDocument/2006/relationships">
   <p:cSld>
     <p:spTree>
@@ -20010,7 +21485,7 @@
 </p:sld>
 </file>
 
-<file path=ppt/slides/slide6.xml><?xml version="1.0" encoding="utf-8"?>
+<file path=ppt/slides/slide9.xml><?xml version="1.0" encoding="utf-8"?>
 <p:sld xmlns:a="http://schemas.openxmlformats.org/drawingml/2006/main" xmlns:p="http://schemas.openxmlformats.org/presentationml/2006/main" xmlns:r="http://schemas.openxmlformats.org/officeDocument/2006/relationships">
   <p:cSld>
     <p:spTree>
@@ -20071,7 +21546,7 @@
         <p:spPr>
           <a:xfrm>
             <a:off x="777240" y="2042769"/>
-            <a:ext cx="1904329" cy="2032711"/>
+            <a:ext cx="1583375" cy="2032711"/>
           </a:xfrm>
           <a:prstGeom prst="roundRect">
             <a:avLst>
@@ -20108,7 +21583,7 @@
           <a:p>
             <a:pPr algn="ctr"/>
             <a:r>
-              <a:rPr sz="1404" b="1">
+              <a:rPr sz="1287" b="1">
                 <a:solidFill>
                   <a:srgbClr val="FF3621"/>
                 </a:solidFill>
@@ -20120,7 +21595,7 @@
           <a:p>
             <a:pPr algn="ctr"/>
             <a:r>
-              <a:rPr sz="1404" b="0">
+              <a:rPr sz="1287" b="0">
                 <a:solidFill>
                   <a:srgbClr val="1B3037"/>
                 </a:solidFill>
@@ -20139,8 +21614,8 @@
         </p:nvCxnSpPr>
         <p:spPr>
           <a:xfrm>
-            <a:off x="2681569" y="3059125"/>
-            <a:ext cx="213970" cy="0"/>
+            <a:off x="2360615" y="3059125"/>
+            <a:ext cx="181874" cy="0"/>
           </a:xfrm>
           <a:prstGeom prst="line">
             <a:avLst/>
@@ -20176,8 +21651,8 @@
         </p:nvSpPr>
         <p:spPr>
           <a:xfrm>
-            <a:off x="2895539" y="2042769"/>
-            <a:ext cx="1904329" cy="2032711"/>
+            <a:off x="2542489" y="2042769"/>
+            <a:ext cx="1583375" cy="2032711"/>
           </a:xfrm>
           <a:prstGeom prst="roundRect">
             <a:avLst>
@@ -20214,7 +21689,7 @@
           <a:p>
             <a:pPr algn="ctr"/>
             <a:r>
-              <a:rPr sz="1404" b="1">
+              <a:rPr sz="1287" b="1">
                 <a:solidFill>
                   <a:srgbClr val="FF3621"/>
                 </a:solidFill>
@@ -20226,7 +21701,7 @@
           <a:p>
             <a:pPr algn="ctr"/>
             <a:r>
-              <a:rPr sz="1404" b="0">
+              <a:rPr sz="1287" b="0">
                 <a:solidFill>
                   <a:srgbClr val="1B3037"/>
                 </a:solidFill>
@@ -20245,8 +21720,8 @@
         </p:nvCxnSpPr>
         <p:spPr>
           <a:xfrm>
-            <a:off x="4799868" y="3059125"/>
-            <a:ext cx="213970" cy="0"/>
+            <a:off x="4125864" y="3059125"/>
+            <a:ext cx="181874" cy="0"/>
           </a:xfrm>
           <a:prstGeom prst="line">
             <a:avLst/>
@@ -20282,8 +21757,8 @@
         </p:nvSpPr>
         <p:spPr>
           <a:xfrm>
-            <a:off x="5013838" y="2042769"/>
-            <a:ext cx="1904329" cy="2032711"/>
+            <a:off x="4307738" y="2042769"/>
+            <a:ext cx="1583375" cy="2032711"/>
           </a:xfrm>
           <a:prstGeom prst="roundRect">
             <a:avLst>
@@ -20320,7 +21795,7 @@
           <a:p>
             <a:pPr algn="ctr"/>
             <a:r>
-              <a:rPr sz="1404" b="1">
+              <a:rPr sz="1287" b="1">
                 <a:solidFill>
                   <a:srgbClr val="FF3621"/>
                 </a:solidFill>
@@ -20332,13 +21807,13 @@
           <a:p>
             <a:pPr algn="ctr"/>
             <a:r>
-              <a:rPr sz="1404" b="0">
+              <a:rPr sz="1287" b="0">
                 <a:solidFill>
                   <a:srgbClr val="1B3037"/>
                 </a:solidFill>
                 <a:latin typeface="DM Sans"/>
               </a:rPr>
-              <a:t>Review queue: readings needing a human, unexpectedly high ones, one unreadable dial</a:t>
+              <a:t>67% need no one; the queue shows the readings that need a person</a:t>
             </a:r>
           </a:p>
         </p:txBody>
@@ -20351,8 +21826,8 @@
         </p:nvCxnSpPr>
         <p:spPr>
           <a:xfrm>
-            <a:off x="6918167" y="3059125"/>
-            <a:ext cx="213970" cy="0"/>
+            <a:off x="5891113" y="3059125"/>
+            <a:ext cx="181874" cy="0"/>
           </a:xfrm>
           <a:prstGeom prst="line">
             <a:avLst/>
@@ -20388,8 +21863,8 @@
         </p:nvSpPr>
         <p:spPr>
           <a:xfrm>
-            <a:off x="7132137" y="2042769"/>
-            <a:ext cx="1904329" cy="2032711"/>
+            <a:off x="6072987" y="2042769"/>
+            <a:ext cx="1583375" cy="2032711"/>
           </a:xfrm>
           <a:prstGeom prst="roundRect">
             <a:avLst>
@@ -20426,7 +21901,7 @@
           <a:p>
             <a:pPr algn="ctr"/>
             <a:r>
-              <a:rPr sz="1404" b="1">
+              <a:rPr sz="1287" b="1">
                 <a:solidFill>
                   <a:srgbClr val="FF3621"/>
                 </a:solidFill>
@@ -20438,7 +21913,7 @@
           <a:p>
             <a:pPr algn="ctr"/>
             <a:r>
-              <a:rPr sz="1404" b="0">
+              <a:rPr sz="1287" b="0">
                 <a:solidFill>
                   <a:srgbClr val="1B3037"/>
                 </a:solidFill>
@@ -20457,8 +21932,8 @@
         </p:nvCxnSpPr>
         <p:spPr>
           <a:xfrm>
-            <a:off x="9036466" y="3059125"/>
-            <a:ext cx="213970" cy="0"/>
+            <a:off x="7656362" y="3059125"/>
+            <a:ext cx="181874" cy="0"/>
           </a:xfrm>
           <a:prstGeom prst="line">
             <a:avLst/>
@@ -20494,8 +21969,8 @@
         </p:nvSpPr>
         <p:spPr>
           <a:xfrm>
-            <a:off x="9250436" y="2042769"/>
-            <a:ext cx="1904329" cy="2032711"/>
+            <a:off x="7838236" y="2042769"/>
+            <a:ext cx="1583375" cy="2032711"/>
           </a:xfrm>
           <a:prstGeom prst="roundRect">
             <a:avLst>
@@ -20532,7 +22007,7 @@
           <a:p>
             <a:pPr algn="ctr"/>
             <a:r>
-              <a:rPr sz="1404" b="1">
+              <a:rPr sz="1287" b="1">
                 <a:solidFill>
                   <a:srgbClr val="FF3621"/>
                 </a:solidFill>
@@ -20544,20 +22019,126 @@
           <a:p>
             <a:pPr algn="ctr"/>
             <a:r>
-              <a:rPr sz="1404" b="0">
+              <a:rPr sz="1287" b="0">
                 <a:solidFill>
                   <a:srgbClr val="1B3037"/>
                 </a:solidFill>
                 <a:latin typeface="DM Sans"/>
               </a:rPr>
-              <a:t>“Which readings have needed human intervention?” — Genie answers with SQL</a:t>
+              <a:t>“Which locations have the most low-confidence readings?” — Genie answers with SQL</a:t>
+            </a:r>
+          </a:p>
+        </p:txBody>
+      </p:sp>
+      <p:cxnSp>
+        <p:nvCxnSpPr>
+          <p:cNvPr id="14" name="Connector 13"/>
+          <p:cNvCxnSpPr/>
+          <p:nvPr/>
+        </p:nvCxnSpPr>
+        <p:spPr>
+          <a:xfrm>
+            <a:off x="9421611" y="3059125"/>
+            <a:ext cx="181875" cy="0"/>
+          </a:xfrm>
+          <a:prstGeom prst="line">
+            <a:avLst/>
+          </a:prstGeom>
+          <a:ln w="15875">
+            <a:solidFill>
+              <a:srgbClr val="1B3037"/>
+            </a:solidFill>
+            <a:headEnd type="none" w="med" len="med"/>
+            <a:tailEnd type="triangle" w="med" len="med"/>
+          </a:ln>
+        </p:spPr>
+        <p:style>
+          <a:lnRef idx="2">
+            <a:schemeClr val="accent1"/>
+          </a:lnRef>
+          <a:fillRef idx="0">
+            <a:schemeClr val="accent1"/>
+          </a:fillRef>
+          <a:effectRef idx="1">
+            <a:schemeClr val="accent1"/>
+          </a:effectRef>
+          <a:fontRef idx="minor">
+            <a:schemeClr val="tx1"/>
+          </a:fontRef>
+        </p:style>
+      </p:cxnSp>
+      <p:sp>
+        <p:nvSpPr>
+          <p:cNvPr id="15" name="Rounded Rectangle 14"/>
+          <p:cNvSpPr/>
+          <p:nvPr/>
+        </p:nvSpPr>
+        <p:spPr>
+          <a:xfrm>
+            <a:off x="9603486" y="2042769"/>
+            <a:ext cx="1583375" cy="2032711"/>
+          </a:xfrm>
+          <a:prstGeom prst="roundRect">
+            <a:avLst>
+              <a:gd name="adj" fmla="val 14000"/>
+            </a:avLst>
+          </a:prstGeom>
+          <a:solidFill>
+            <a:srgbClr val="FFFFFF"/>
+          </a:solidFill>
+          <a:ln w="9525">
+            <a:solidFill>
+              <a:srgbClr val="618793"/>
+            </a:solidFill>
+          </a:ln>
+          <a:effectLst/>
+        </p:spPr>
+        <p:style>
+          <a:lnRef idx="1">
+            <a:schemeClr val="accent1"/>
+          </a:lnRef>
+          <a:fillRef idx="3">
+            <a:schemeClr val="accent1"/>
+          </a:fillRef>
+          <a:effectRef idx="2">
+            <a:schemeClr val="accent1"/>
+          </a:effectRef>
+          <a:fontRef idx="minor">
+            <a:schemeClr val="lt1"/>
+          </a:fontRef>
+        </p:style>
+        <p:txBody>
+          <a:bodyPr rtlCol="0" anchor="ctr" wrap="square" lIns="45720" rIns="45720"/>
+          <a:lstStyle/>
+          <a:p>
+            <a:pPr algn="ctr"/>
+            <a:r>
+              <a:rPr sz="1287" b="1">
+                <a:solidFill>
+                  <a:srgbClr val="FF3621"/>
+                </a:solidFill>
+                <a:latin typeface="DM Sans"/>
+              </a:rPr>
+              <a:t>6  Trust</a:t>
+            </a:r>
+          </a:p>
+          <a:p>
+            <a:pPr algn="ctr"/>
+            <a:r>
+              <a:rPr sz="1287" b="0">
+                <a:solidFill>
+                  <a:srgbClr val="1B3037"/>
+                </a:solidFill>
+                <a:latin typeface="DM Sans"/>
+              </a:rPr>
+              <a:t>AI model &amp; usage: cost per reading, confidence vs threshold, correction rate</a:t>
             </a:r>
           </a:p>
         </p:txBody>
       </p:sp>
       <p:sp>
         <p:nvSpPr>
-          <p:cNvPr id="14" name="TextBox 13"/>
+          <p:cNvPr id="16" name="TextBox 15"/>
           <p:cNvSpPr txBox="1"/>
           <p:nvPr/>
         </p:nvSpPr>
@@ -20586,480 +22167,6 @@
                 <a:latin typeface="DM Sans"/>
               </a:rPr>
               <a:t>Everything shown runs on synthetic metadata and publicly licensed gauge photos</a:t>
-            </a:r>
-          </a:p>
-        </p:txBody>
-      </p:sp>
-    </p:spTree>
-  </p:cSld>
-  <p:clrMapOvr>
-    <a:masterClrMapping/>
-  </p:clrMapOvr>
-</p:sld>
-</file>
-
-<file path=ppt/slides/slide7.xml><?xml version="1.0" encoding="utf-8"?>
-<p:sld xmlns:a="http://schemas.openxmlformats.org/drawingml/2006/main" xmlns:p="http://schemas.openxmlformats.org/presentationml/2006/main" xmlns:r="http://schemas.openxmlformats.org/officeDocument/2006/relationships">
-  <p:cSld>
-    <p:spTree>
-      <p:nvGrpSpPr>
-        <p:cNvPr id="1" name=""/>
-        <p:cNvGrpSpPr/>
-        <p:nvPr/>
-      </p:nvGrpSpPr>
-      <p:grpSpPr/>
-      <p:sp>
-        <p:nvSpPr>
-          <p:cNvPr id="2" name="Title 1"/>
-          <p:cNvSpPr>
-            <a:spLocks noGrp="1"/>
-          </p:cNvSpPr>
-          <p:nvPr>
-            <p:ph type="title"/>
-          </p:nvPr>
-        </p:nvSpPr>
-        <p:spPr/>
-        <p:txBody>
-          <a:bodyPr/>
-          <a:lstStyle/>
-          <a:p>
-            <a:r>
-              <a:t>Governed AI with a human in the loop</a:t>
-            </a:r>
-          </a:p>
-        </p:txBody>
-      </p:sp>
-      <p:sp>
-        <p:nvSpPr>
-          <p:cNvPr id="3" name="Text Placeholder 2"/>
-          <p:cNvSpPr>
-            <a:spLocks noGrp="1"/>
-          </p:cNvSpPr>
-          <p:nvPr>
-            <p:ph type="body" idx="1"/>
-          </p:nvPr>
-        </p:nvSpPr>
-        <p:spPr/>
-        <p:txBody>
-          <a:bodyPr/>
-          <a:lstStyle/>
-          <a:p>
-            <a:r>
-              <a:t>Confidence below 70%, unreadable dials and unexpectedly high readings always go to a reviewer</a:t>
-            </a:r>
-          </a:p>
-          <a:p>
-            <a:r>
-              <a:t>Decisions are appended, never overwritten</a:t>
-            </a:r>
-          </a:p>
-          <a:p>
-            <a:r>
-              <a:t>Human correction rate tracked as live accuracy</a:t>
-            </a:r>
-          </a:p>
-        </p:txBody>
-      </p:sp>
-      <p:sp>
-        <p:nvSpPr>
-          <p:cNvPr id="4" name="Text Placeholder 3"/>
-          <p:cNvSpPr>
-            <a:spLocks noGrp="1"/>
-          </p:cNvSpPr>
-          <p:nvPr>
-            <p:ph type="body" idx="2"/>
-          </p:nvPr>
-        </p:nvSpPr>
-        <p:spPr/>
-        <p:txBody>
-          <a:bodyPr/>
-          <a:lstStyle/>
-          <a:p>
-            <a:r>
-              <a:t>Analysts see the gold table only; the app reads images read-only</a:t>
-            </a:r>
-          </a:p>
-          <a:p>
-            <a:r>
-              <a:t>Lineage from raw image to the answer in Genie</a:t>
-            </a:r>
-          </a:p>
-          <a:p>
-            <a:r>
-              <a:t>Genie runs with the user's own permissions</a:t>
-            </a:r>
-          </a:p>
-        </p:txBody>
-      </p:sp>
-      <p:sp>
-        <p:nvSpPr>
-          <p:cNvPr id="5" name="Text Placeholder 4"/>
-          <p:cNvSpPr>
-            <a:spLocks noGrp="1"/>
-          </p:cNvSpPr>
-          <p:nvPr>
-            <p:ph type="body" idx="3"/>
-          </p:nvPr>
-        </p:nvSpPr>
-        <p:spPr/>
-        <p:txBody>
-          <a:bodyPr/>
-          <a:lstStyle/>
-          <a:p>
-            <a:r>
-              <a:t>Every model call attributed: requester, tokens, latency, status</a:t>
-            </a:r>
-          </a:p>
-          <a:p>
-            <a:r>
-              <a:t>Model access governed by UC EXECUTE</a:t>
-            </a:r>
-          </a:p>
-          <a:p>
-            <a:r>
-              <a:t>Swap or fall back models without pipeline changes</a:t>
-            </a:r>
-          </a:p>
-        </p:txBody>
-      </p:sp>
-      <p:sp>
-        <p:nvSpPr>
-          <p:cNvPr id="6" name="Subtitle 5"/>
-          <p:cNvSpPr>
-            <a:spLocks noGrp="1"/>
-          </p:cNvSpPr>
-          <p:nvPr>
-            <p:ph type="subTitle" idx="4"/>
-          </p:nvPr>
-        </p:nvSpPr>
-        <p:spPr/>
-        <p:txBody>
-          <a:bodyPr/>
-          <a:lstStyle/>
-          <a:p>
-            <a:r>
-              <a:t>Human in the loop</a:t>
-            </a:r>
-          </a:p>
-        </p:txBody>
-      </p:sp>
-      <p:sp>
-        <p:nvSpPr>
-          <p:cNvPr id="7" name="Subtitle 6"/>
-          <p:cNvSpPr>
-            <a:spLocks noGrp="1"/>
-          </p:cNvSpPr>
-          <p:nvPr>
-            <p:ph type="subTitle" idx="5"/>
-          </p:nvPr>
-        </p:nvSpPr>
-        <p:spPr/>
-        <p:txBody>
-          <a:bodyPr/>
-          <a:lstStyle/>
-          <a:p>
-            <a:r>
-              <a:t>Unity Catalog</a:t>
-            </a:r>
-          </a:p>
-        </p:txBody>
-      </p:sp>
-      <p:sp>
-        <p:nvSpPr>
-          <p:cNvPr id="8" name="Subtitle 7"/>
-          <p:cNvSpPr>
-            <a:spLocks noGrp="1"/>
-          </p:cNvSpPr>
-          <p:nvPr>
-            <p:ph type="subTitle" idx="6"/>
-          </p:nvPr>
-        </p:nvSpPr>
-        <p:spPr/>
-        <p:txBody>
-          <a:bodyPr/>
-          <a:lstStyle/>
-          <a:p>
-            <a:r>
-              <a:t>Unity AI Gateway</a:t>
-            </a:r>
-          </a:p>
-        </p:txBody>
-      </p:sp>
-      <p:sp>
-        <p:nvSpPr>
-          <p:cNvPr id="9" name="Text Placeholder 8"/>
-          <p:cNvSpPr>
-            <a:spLocks noGrp="1"/>
-          </p:cNvSpPr>
-          <p:nvPr>
-            <p:ph type="body" idx="7"/>
-          </p:nvPr>
-        </p:nvSpPr>
-        <p:spPr/>
-        <p:txBody>
-          <a:bodyPr/>
-          <a:lstStyle/>
-          <a:p>
-            <a:r>
-              <a:t>AI reads, people decide where it matters, the platform keeps the record</a:t>
-            </a:r>
-          </a:p>
-        </p:txBody>
-      </p:sp>
-    </p:spTree>
-  </p:cSld>
-  <p:clrMapOvr>
-    <a:masterClrMapping/>
-  </p:clrMapOvr>
-</p:sld>
-</file>
-
-<file path=ppt/slides/slide8.xml><?xml version="1.0" encoding="utf-8"?>
-<p:sld xmlns:a="http://schemas.openxmlformats.org/drawingml/2006/main" xmlns:p="http://schemas.openxmlformats.org/presentationml/2006/main" xmlns:r="http://schemas.openxmlformats.org/officeDocument/2006/relationships">
-  <p:cSld>
-    <p:spTree>
-      <p:nvGrpSpPr>
-        <p:cNvPr id="1" name=""/>
-        <p:cNvGrpSpPr/>
-        <p:nvPr/>
-      </p:nvGrpSpPr>
-      <p:grpSpPr/>
-      <p:sp>
-        <p:nvSpPr>
-          <p:cNvPr id="2" name="Title 1"/>
-          <p:cNvSpPr>
-            <a:spLocks noGrp="1"/>
-          </p:cNvSpPr>
-          <p:nvPr>
-            <p:ph type="title"/>
-          </p:nvPr>
-        </p:nvSpPr>
-        <p:spPr/>
-        <p:txBody>
-          <a:bodyPr/>
-          <a:lstStyle/>
-          <a:p>
-            <a:r>
-              <a:t>Decisions and trade-offs</a:t>
-            </a:r>
-          </a:p>
-        </p:txBody>
-      </p:sp>
-      <p:sp>
-        <p:nvSpPr>
-          <p:cNvPr id="3" name="Text Placeholder 2"/>
-          <p:cNvSpPr>
-            <a:spLocks noGrp="1"/>
-          </p:cNvSpPr>
-          <p:nvPr>
-            <p:ph type="body" idx="1"/>
-          </p:nvPr>
-        </p:nvSpPr>
-        <p:spPr/>
-        <p:txBody>
-          <a:bodyPr/>
-          <a:lstStyle/>
-          <a:p>
-            <a:r>
-              <a:rPr sz="1700"/>
-              <a:t>Foundation vision model via ai_query, not a custom CNN: no labelled data or training; confidence-based review covers the gaps</a:t>
-            </a:r>
-          </a:p>
-          <a:p>
-            <a:r>
-              <a:rPr sz="1700"/>
-              <a:t>Model called inside the streaming table: each image read and billed once; reviewed readings never change on refresh</a:t>
-            </a:r>
-          </a:p>
-          <a:p>
-            <a:r>
-              <a:rPr sz="1700"/>
-              <a:t>Lakebase for the review step: low-latency transactional writes; decisions return to Delta via Lakehouse Sync</a:t>
-            </a:r>
-          </a:p>
-          <a:p>
-            <a:r>
-              <a:rPr sz="1700"/>
-              <a:t>Snapshot sync for serving: gold is a materialized view; at ~120 images/day a snapshot takes seconds</a:t>
-            </a:r>
-          </a:p>
-          <a:p>
-            <a:r>
-              <a:rPr sz="1700"/>
-              <a:t>“Unexpectedly high” = above the gauge's operating limit (default 75% of full scale), so Genie never invents thresholds</a:t>
-            </a:r>
-          </a:p>
-          <a:p>
-            <a:r>
-              <a:rPr sz="1700"/>
-              <a:t>GPT-5.5 chosen after testing 15 vision models: best accuracy among batch-capable models, with a confidence score that separates right from wrong</a:t>
-            </a:r>
-          </a:p>
-        </p:txBody>
-      </p:sp>
-      <p:sp>
-        <p:nvSpPr>
-          <p:cNvPr id="4" name="Text Placeholder 3"/>
-          <p:cNvSpPr>
-            <a:spLocks noGrp="1"/>
-          </p:cNvSpPr>
-          <p:nvPr>
-            <p:ph type="body" idx="2"/>
-          </p:nvPr>
-        </p:nvSpPr>
-        <p:spPr/>
-        <p:txBody>
-          <a:bodyPr/>
-          <a:lstStyle/>
-          <a:p>
-            <a:r>
-              <a:t>Why this approach and not another</a:t>
-            </a:r>
-          </a:p>
-        </p:txBody>
-      </p:sp>
-    </p:spTree>
-  </p:cSld>
-  <p:clrMapOvr>
-    <a:masterClrMapping/>
-  </p:clrMapOvr>
-</p:sld>
-</file>
-
-<file path=ppt/slides/slide9.xml><?xml version="1.0" encoding="utf-8"?>
-<p:sld xmlns:a="http://schemas.openxmlformats.org/drawingml/2006/main" xmlns:p="http://schemas.openxmlformats.org/presentationml/2006/main" xmlns:r="http://schemas.openxmlformats.org/officeDocument/2006/relationships">
-  <p:cSld>
-    <p:spTree>
-      <p:nvGrpSpPr>
-        <p:cNvPr id="1" name=""/>
-        <p:cNvGrpSpPr/>
-        <p:nvPr/>
-      </p:nvGrpSpPr>
-      <p:grpSpPr/>
-      <p:sp>
-        <p:nvSpPr>
-          <p:cNvPr id="2" name="Title 1"/>
-          <p:cNvSpPr>
-            <a:spLocks noGrp="1"/>
-          </p:cNvSpPr>
-          <p:nvPr>
-            <p:ph type="title"/>
-          </p:nvPr>
-        </p:nvSpPr>
-        <p:spPr/>
-        <p:txBody>
-          <a:bodyPr/>
-          <a:lstStyle/>
-          <a:p>
-            <a:r>
-              <a:t>Path to production</a:t>
-            </a:r>
-          </a:p>
-        </p:txBody>
-      </p:sp>
-      <p:sp>
-        <p:nvSpPr>
-          <p:cNvPr id="3" name="Text Placeholder 2"/>
-          <p:cNvSpPr>
-            <a:spLocks noGrp="1"/>
-          </p:cNvSpPr>
-          <p:nvPr>
-            <p:ph type="body" idx="1"/>
-          </p:nvPr>
-        </p:nvSpPr>
-        <p:spPr/>
-        <p:txBody>
-          <a:bodyPr/>
-          <a:lstStyle/>
-          <a:p>
-            <a:r>
-              <a:rPr sz="1600"/>
-              <a:t>Connect the robot fleet's image export to the raw volume (file-arrival trigger in place)</a:t>
-            </a:r>
-          </a:p>
-          <a:p>
-            <a:r>
-              <a:rPr sz="1600"/>
-              <a:t>Load real gauge tags and operating limits from the asset register</a:t>
-            </a:r>
-          </a:p>
-          <a:p>
-            <a:r>
-              <a:rPr sz="1600"/>
-              <a:t>Alert on unexpectedly high readings into the maintenance work-order system</a:t>
-            </a:r>
-          </a:p>
-          <a:p>
-            <a:r>
-              <a:rPr sz="1600"/>
-              <a:t>Promote with Declarative Automation Bundles (dev → prod) and named reviewer / analyst groups</a:t>
-            </a:r>
-          </a:p>
-        </p:txBody>
-      </p:sp>
-      <p:sp>
-        <p:nvSpPr>
-          <p:cNvPr id="4" name="Text Placeholder 3"/>
-          <p:cNvSpPr>
-            <a:spLocks noGrp="1"/>
-          </p:cNvSpPr>
-          <p:nvPr>
-            <p:ph type="body" idx="2"/>
-          </p:nvPr>
-        </p:nvSpPr>
-        <p:spPr/>
-        <p:txBody>
-          <a:bodyPr/>
-          <a:lstStyle/>
-          <a:p>
-            <a:r>
-              <a:rPr sz="1600"/>
-              <a:t>Pilot success criteria</a:t>
-            </a:r>
-          </a:p>
-          <a:p>
-            <a:r>
-              <a:rPr sz="1600"/>
-              <a:t>One site, [TBD] weeks</a:t>
-            </a:r>
-          </a:p>
-          <a:p>
-            <a:r>
-              <a:rPr sz="1600"/>
-              <a:t>Human correction rate below [TBD]%</a:t>
-            </a:r>
-          </a:p>
-          <a:p>
-            <a:r>
-              <a:rPr sz="1600"/>
-              <a:t>[TBD] hours of manual rounds removed</a:t>
-            </a:r>
-          </a:p>
-          <a:p>
-            <a:r>
-              <a:rPr sz="1600"/>
-              <a:t>Every reading traceable from photo to answer</a:t>
-            </a:r>
-          </a:p>
-        </p:txBody>
-      </p:sp>
-      <p:sp>
-        <p:nvSpPr>
-          <p:cNvPr id="5" name="Text Placeholder 4"/>
-          <p:cNvSpPr>
-            <a:spLocks noGrp="1"/>
-          </p:cNvSpPr>
-          <p:nvPr>
-            <p:ph type="body" idx="3"/>
-          </p:nvPr>
-        </p:nvSpPr>
-        <p:spPr/>
-        <p:txBody>
-          <a:bodyPr/>
-          <a:lstStyle/>
-          <a:p>
-            <a:r>
-              <a:t>From one demo round to a site pilot</a:t>
             </a:r>
           </a:p>
         </p:txBody>

</xml_diff>

<commit_message>
Deck + README: value model instead of test-round KPIs; fill TBDs
Replaces the 30-photo test results with an illustrative site value model
(500 gauges twice a day): ~4,900 hours a year back, ~$15k a year AI cost vs
~$180k vendor fees, and downtime at ~$0.8M an hour (Siemens 2024). Assumptions
are stated on the slide. Fills the remaining TBDs: ~2,200 operator hours a year
out of process areas, and pilot targets (8 weeks, <= 1 in 5 reviewed, >= 95%
within +/-2% of full scale).

Co-authored-by: Isaac <no-reply@databricks.com>
</commit_message>
<xml_diff>
--- a/deck/pressure-gauge-reader.pptx
+++ b/deck/pressure-gauge-reader.pptx
@@ -821,7 +821,7 @@
           <a:lstStyle/>
           <a:p>
             <a:r>
-              <a:t>Lead with the outcome for the executive sponsor: gauge readings are the first use case; the same platform turns the same photos into leak, corrosion and damage findings. Numbers from the build run (evidence/04_readings_summary.md, 01_pipeline_run.md, 07_gateway.md). Still to model with the customer: hours of manual rounds removed per site x loaded cost, and vendor cost per image avoided.</a:t>
+              <a:t>Lead with the value for the executive sponsor. This is a value model, not a test result: replace the assumptions with Northbay's gauge count, rounds per day, minutes per reading and current vendor fee. Hours: 500 gauges x 2 rounds x 365 days = 365,000 readings; at 1 minute each = ~6,100 hours; reviewing 1 in 5 = ~1,200 hours; ~4,900 hours saved (~2.9 FTE at 1,700 hours). AI cost: 365,000 x $0.042 = ~$15k. Vendor: 365,000 x $0.50 = ~$180k. Downtime: $253M / 326 hours = ~$776k an hour, ~50x the annual AI cost. Gauge readings are the first use case; the same photos also give leak, corrosion and damage findings at no extra capture cost.</a:t>
             </a:r>
           </a:p>
         </p:txBody>
@@ -1175,7 +1175,7 @@
           <a:p/>
           <a:p>
             <a:r>
-              <a:t>DEMO (8-10 min): 1 Land: 30 photos + metadata in the raw volume. 2 Read: the pipeline reads each dial once. 3 Triage: 67% need no one; open the review queue. 4 Correct: fix PI-3102 (5.0 → 1.0 bar) with a reason. 5 Ask: Genie, 'Which locations have the most low-confidence readings?'. 6 Trust: How it works + AI model &amp; usage pages.</a:t>
+              <a:t>DEMO (8-10 min): 1 Land: 30 photos + metadata in the raw volume. 2 Read: the pipeline reads each dial once. 3 Triage: the queue shows only the readings that need a person. 4 Correct: fix PI-3102 (5.0 → 1.0 bar) with a reason. 5 Ask: Genie, 'Which locations have the most low-confidence readings?'. 6 Trust: How it works + AI model &amp; usage pages.</a:t>
             </a:r>
           </a:p>
         </p:txBody>
@@ -17485,19 +17485,25 @@
           <a:p>
             <a:r>
               <a:rPr sz="1600"/>
-              <a:t>One site, [TBD] weeks</a:t>
+              <a:t>One site, 8 weeks, ~500 gauges</a:t>
             </a:r>
           </a:p>
           <a:p>
             <a:r>
               <a:rPr sz="1600"/>
-              <a:t>Human correction rate below [TBD]%</a:t>
+              <a:t>At most 1 in 5 readings sent to review</a:t>
             </a:r>
           </a:p>
           <a:p>
             <a:r>
               <a:rPr sz="1600"/>
-              <a:t>[TBD] hours of manual rounds removed</a:t>
+              <a:t>≥ 95% of auto-accepted readings within ±2% of full scale (weekly spot check)</a:t>
+            </a:r>
+          </a:p>
+          <a:p>
+            <a:r>
+              <a:rPr sz="1600"/>
+              <a:t>~4,900 hours a year of reading and re-checking removed (run rate)</a:t>
             </a:r>
           </a:p>
           <a:p>
@@ -17602,7 +17608,7 @@
           <a:lstStyle/>
           <a:p>
             <a:r>
-              <a:t>Every photo, turned into trusted data</a:t>
+              <a:t>Where the value comes from</a:t>
             </a:r>
           </a:p>
         </p:txBody>
@@ -17623,12 +17629,20 @@
           <a:lstStyle/>
           <a:p>
             <a:r>
-              <a:t>20 of 30 readings read and accepted by AI</a:t>
+              <a:rPr sz="1500"/>
+              <a:t>365,000 readings a year, each transcribed or re-checked by hand: ~6,100 hours at 1 minute each¹</a:t>
             </a:r>
           </a:p>
           <a:p>
             <a:r>
-              <a:t>Reviewers check 10, not 30 — no manual transcription</a:t>
+              <a:rPr sz="1500"/>
+              <a:t>With AI, people check only the uncertain ones (target: 1 in 5)</a:t>
+            </a:r>
+          </a:p>
+          <a:p>
+            <a:r>
+              <a:rPr sz="1500"/>
+              <a:t>About 3 people's time, freed for maintenance</a:t>
             </a:r>
           </a:p>
         </p:txBody>
@@ -17649,12 +17663,20 @@
           <a:lstStyle/>
           <a:p>
             <a:r>
-              <a:t>One pipeline run read the whole round, each photo once</a:t>
+              <a:rPr sz="1500"/>
+              <a:t>365,000 photos × ~$0.04 per photo at list price²</a:t>
             </a:r>
           </a:p>
           <a:p>
             <a:r>
-              <a:t>Excursions surfaced the same shift</a:t>
+              <a:rPr sz="1500"/>
+              <a:t>vs. ~$180k a year at a $0.50 per-image vendor fee¹</a:t>
+            </a:r>
+          </a:p>
+          <a:p>
+            <a:r>
+              <a:rPr sz="1500"/>
+              <a:t>No model to train, host or maintain</a:t>
             </a:r>
           </a:p>
         </p:txBody>
@@ -17675,12 +17697,20 @@
           <a:lstStyle/>
           <a:p>
             <a:r>
-              <a:t>AI cost at list price, every call attributed</a:t>
+              <a:rPr sz="1500"/>
+              <a:t>Excursions flagged the same shift, not at the next manual round</a:t>
             </a:r>
           </a:p>
           <a:p>
             <a:r>
-              <a:t>100% of uncertain or unexpectedly high readings checked by a person</a:t>
+              <a:rPr sz="1500"/>
+              <a:t>Unplanned downtime costs a large plant ~$0.8M an hour³</a:t>
+            </a:r>
+          </a:p>
+          <a:p>
+            <a:r>
+              <a:rPr sz="1500"/>
+              <a:t>Avoiding a single hour is worth ~50× the annual AI cost</a:t>
             </a:r>
           </a:p>
         </p:txBody>
@@ -17701,7 +17731,7 @@
           <a:lstStyle/>
           <a:p>
             <a:r>
-              <a:t>67% need no one</a:t>
+              <a:t>~4,900 hours a year</a:t>
             </a:r>
           </a:p>
         </p:txBody>
@@ -17722,7 +17752,7 @@
           <a:lstStyle/>
           <a:p>
             <a:r>
-              <a:t>&lt; 3 minutes</a:t>
+              <a:t>~$15k a year AI cost</a:t>
             </a:r>
           </a:p>
         </p:txBody>
@@ -17743,7 +17773,7 @@
           <a:lstStyle/>
           <a:p>
             <a:r>
-              <a:t>~$0.04 per reading</a:t>
+              <a:t>Earlier warnings</a:t>
             </a:r>
           </a:p>
         </p:txBody>
@@ -17764,7 +17794,42 @@
           <a:lstStyle/>
           <a:p>
             <a:r>
-              <a:t>What changes — measured on the build round: 30 gauges, 2 sites</a:t>
+              <a:t>Illustrative site: 500 gauges, photographed twice a day</a:t>
+            </a:r>
+          </a:p>
+        </p:txBody>
+      </p:sp>
+      <p:sp>
+        <p:nvSpPr>
+          <p:cNvPr id="10" name="TextBox 9"/>
+          <p:cNvSpPr txBox="1"/>
+          <p:nvPr/>
+        </p:nvSpPr>
+        <p:spPr>
+          <a:xfrm>
+            <a:off x="758952" y="6199632"/>
+            <a:ext cx="10661904" cy="274320"/>
+          </a:xfrm>
+          <a:prstGeom prst="rect">
+            <a:avLst/>
+          </a:prstGeom>
+          <a:noFill/>
+        </p:spPr>
+        <p:txBody>
+          <a:bodyPr wrap="square" anchor="t" lIns="45720" rIns="45720">
+            <a:spAutoFit/>
+          </a:bodyPr>
+          <a:lstStyle/>
+          <a:p>
+            <a:pPr algn="l"/>
+            <a:r>
+              <a:rPr sz="900" b="0">
+                <a:solidFill>
+                  <a:srgbClr val="5F6B70"/>
+                </a:solidFill>
+                <a:latin typeface="DM Sans"/>
+              </a:rPr>
+              <a:t>¹ Assumptions to replace with Northbay's numbers: 1 min per reading, $0.50 per image vendor fee.   ² Measured tokens per photo × GPT-5.5 list price.   ³ Siemens, The True Cost of Downtime 2024.</a:t>
             </a:r>
           </a:p>
         </p:txBody>
@@ -17825,13 +17890,13 @@
           <a:p>
             <a:r>
               <a:rPr sz="1600"/>
-              <a:t>Fewer people in hazardous areas for routine rounds: [TBD] exposure hours avoided per year</a:t>
+              <a:t>Robot rounds keep ~2,200 operator hours a year out of process areas (2 rounds a day × ~3 hours)</a:t>
             </a:r>
           </a:p>
           <a:p>
             <a:r>
               <a:rPr sz="1600"/>
-              <a:t>Vendor dependency removed: ~$0.04 per reading on the platform vs. [TBD] per image today</a:t>
+              <a:t>Vendor dependency removed: ~$15k a year on the platform vs. ~$180k in per-image fees</a:t>
             </a:r>
           </a:p>
           <a:p>

</xml_diff>

<commit_message>
Submission pack: answers, AI usage log, deck PDF, run of show
SUBMISSION.md answers the four submission questions; BUILD.md records the AI
workflow, decisions and session ID; deck/pressure-gauge-reader.pdf is the
export; the demo script moves to slide 7's notes (demo after the comparison).

Co-authored-by: Isaac <no-reply@databricks.com>
</commit_message>
<xml_diff>
--- a/deck/pressure-gauge-reader.pptx
+++ b/deck/pressure-gauge-reader.pptx
@@ -1111,7 +1111,7 @@
           <a:lstStyle/>
           <a:p>
             <a:r>
-              <a:t>Bespoke gauge-reading pipelines chain several models: detect the gauge, segment the needle, find the scale notches, fit an ellipse, OCR the scale markings (ETH Zurich, ICRA 2024). Each new dial type or defect adds work. A foundation model reads the dial in one call, and the platform adds the review loop, governance and cost control.</a:t>
+              <a:t>Bespoke gauge-reading pipelines chain several models: detect the gauge, segment the needle, find the scale notches, fit an ellipse, OCR the scale markings (ETH Zurich, ICRA 2024). Each new dial type or defect adds work. A foundation model reads the dial in one call, and the platform adds the review loop, governance and cost control. DEMO NEXT (8-18 min, then return to slide 8 or straight to slide 9): 1 Review queue: the outcome panel and the Needs review tab (people only check these). 2 Correct PI-3102: zoom into the photo, override 5.0 -&gt; 1.0 bar with a reason (human in the loop). 3 Ask Genie: 'Which locations have the most low-confidence readings?' and expand the SQL. 4 AI model &amp; usage: cost per reading and the confidence spread against the 70% review line (governed AI). 5 How it works: click through the steps and end on the sync-back loop ('your correction just flowed back here').</a:t>
             </a:r>
           </a:p>
         </p:txBody>
@@ -1169,13 +1169,7 @@
           <a:lstStyle/>
           <a:p>
             <a:r>
-              <a:t>Walk left to right: land, read, refine, serve, review, ask. Point out the closed loop (dashed arrow) and the Unity Catalog band under everything. Governed AI: low-confidence, unreadable and unexpectedly high readings always go to a reviewer; decisions are appended, never overwritten; the human correction rate is the live accuracy check. Analysts see the gold table only, Genie runs with the user's own permissions, and every model call is attributed in Unity AI Gateway.</a:t>
-            </a:r>
-          </a:p>
-          <a:p/>
-          <a:p>
-            <a:r>
-              <a:t>DEMO (8-10 min): 1 Land: 30 photos + metadata in the raw volume. 2 Read: the pipeline reads each dial once. 3 Triage: the queue shows only the readings that need a person. 4 Correct: fix PI-3102 (5.0 → 1.0 bar) with a reason. 5 Ask: Genie, 'Which locations have the most low-confidence readings?'. 6 Trust: How it works + AI model &amp; usage pages.</a:t>
+              <a:t>Walk left to right: land, read, refine, serve, review, ask. Point out the closed loop (dashed arrow) and the Unity Catalog band under everything. Governed AI: low-confidence, unreadable and unexpectedly high readings always go to a reviewer; decisions are appended, never overwritten; the human correction rate is the live accuracy check. Analysts see the gold table only, Genie runs with the user's own permissions, and every model call is attributed in Unity AI Gateway. After the demo, use this slide as a quick recap (or skip it).</a:t>
             </a:r>
           </a:p>
         </p:txBody>

</xml_diff>

<commit_message>
Deck: evidence-of-execution appendix and persona scorecard metrics
Appendix A-D carry real run output as text (pipeline event log and
expectations, Unity AI Gateway usage, grants and lineage, Lakebase query,
correction round trip, live app API, Genie SQL and answers). The persona slide
maps each value lever to the metrics each leader is measured on. PDF
re-exported.

Co-authored-by: Isaac <no-reply@databricks.com>
</commit_message>
<xml_diff>
--- a/deck/pressure-gauge-reader.pptx
+++ b/deck/pressure-gauge-reader.pptx
@@ -20,6 +20,10 @@
     <p:sldId id="264" r:id="rId25"/>
     <p:sldId id="265" r:id="rId26"/>
     <p:sldId id="266" r:id="rId27"/>
+    <p:sldId id="267" r:id="rId28"/>
+    <p:sldId id="268" r:id="rId29"/>
+    <p:sldId id="269" r:id="rId30"/>
+    <p:sldId id="270" r:id="rId31"/>
   </p:sldIdLst>
   <p:sldSz cy="6858000" cx="12188950"/>
   <p:notesSz cx="6858000" cy="9144000"/>
@@ -879,7 +883,7 @@
           <a:lstStyle/>
           <a:p>
             <a:r>
-              <a:t>Frame value for both personas the AI roleplay will play: the business stakeholder and the technical/domain stakeholder.</a:t>
+              <a:t>Frame value for both personas the AI roleplay will play. Tie each lever to the scorecard metric: for the VP Operations / HSE, TRIR and process-safety events (exposure hours), plant availability (downtime avoided) and opex (vendor fees); for the reliability lead, unplanned downtime hours, MTBF and maintenance backlog / PM compliance.</a:t>
             </a:r>
           </a:p>
         </p:txBody>
@@ -17576,6 +17580,1665 @@
 </p:sld>
 </file>
 
+<file path=ppt/slides/slide12.xml><?xml version="1.0" encoding="utf-8"?>
+<p:sld xmlns:a="http://schemas.openxmlformats.org/drawingml/2006/main" xmlns:p="http://schemas.openxmlformats.org/presentationml/2006/main" xmlns:r="http://schemas.openxmlformats.org/officeDocument/2006/relationships">
+  <p:cSld>
+    <p:spTree>
+      <p:nvGrpSpPr>
+        <p:cNvPr id="1" name=""/>
+        <p:cNvGrpSpPr/>
+        <p:nvPr/>
+      </p:nvGrpSpPr>
+      <p:grpSpPr/>
+      <p:sp>
+        <p:nvSpPr>
+          <p:cNvPr id="2" name="Title 1"/>
+          <p:cNvSpPr>
+            <a:spLocks noGrp="1"/>
+          </p:cNvSpPr>
+          <p:nvPr>
+            <p:ph type="title"/>
+          </p:nvPr>
+        </p:nvSpPr>
+        <p:spPr/>
+        <p:txBody>
+          <a:bodyPr/>
+          <a:lstStyle/>
+          <a:p>
+            <a:r>
+              <a:t>Appendix A · Pipeline run</a:t>
+            </a:r>
+          </a:p>
+        </p:txBody>
+      </p:sp>
+      <p:sp>
+        <p:nvSpPr>
+          <p:cNvPr id="4" name="Text Placeholder 3"/>
+          <p:cNvSpPr>
+            <a:spLocks noGrp="1"/>
+          </p:cNvSpPr>
+          <p:nvPr>
+            <p:ph type="body" idx="2"/>
+          </p:nvPr>
+        </p:nvSpPr>
+        <p:spPr/>
+        <p:txBody>
+          <a:bodyPr/>
+          <a:lstStyle/>
+          <a:p>
+            <a:r>
+              <a:t>Evidence: Lakeflow event log — 30 photos read once</a:t>
+            </a:r>
+          </a:p>
+        </p:txBody>
+      </p:sp>
+      <p:sp>
+        <p:nvSpPr>
+          <p:cNvPr id="5" name="TextBox 4"/>
+          <p:cNvSpPr txBox="1"/>
+          <p:nvPr/>
+        </p:nvSpPr>
+        <p:spPr>
+          <a:xfrm>
+            <a:off x="758952" y="1783080"/>
+            <a:ext cx="10698480" cy="2651760"/>
+          </a:xfrm>
+          <a:prstGeom prst="rect">
+            <a:avLst/>
+          </a:prstGeom>
+          <a:noFill/>
+        </p:spPr>
+        <p:txBody>
+          <a:bodyPr wrap="square" anchor="t" lIns="36576" rIns="36576" tIns="36576" bIns="36576">
+            <a:spAutoFit/>
+          </a:bodyPr>
+          <a:lstStyle/>
+          <a:p>
+            <a:pPr>
+              <a:spcAft>
+                <a:spcPts val="400"/>
+              </a:spcAft>
+            </a:pPr>
+            <a:r>
+              <a:rPr sz="1300" b="1">
+                <a:solidFill>
+                  <a:srgbClr val="FF3621"/>
+                </a:solidFill>
+                <a:latin typeface="DM Sans"/>
+              </a:rPr>
+              <a:t>Pipeline update (serverless, triggered)</a:t>
+            </a:r>
+          </a:p>
+          <a:p>
+            <a:pPr>
+              <a:spcAft>
+                <a:spcPts val="0"/>
+              </a:spcAft>
+            </a:pPr>
+            <a:r>
+              <a:rPr sz="1050">
+                <a:solidFill>
+                  <a:srgbClr val="1B3037"/>
+                </a:solidFill>
+                <a:latin typeface="Courier New"/>
+              </a:rPr>
+              <a:t>update 177c2109-d3f2-49aa-846d-8b434c3b6861   COMPLETED   full_refresh=False</a:t>
+            </a:r>
+          </a:p>
+          <a:p>
+            <a:pPr>
+              <a:spcAft>
+                <a:spcPts val="0"/>
+              </a:spcAft>
+            </a:pPr>
+            <a:r>
+              <a:rPr sz="1050">
+                <a:solidFill>
+                  <a:srgbClr val="1B3037"/>
+                </a:solidFill>
+                <a:latin typeface="Courier New"/>
+              </a:rPr>
+              <a:t>started 2026-10-06 12:49:11 UTC   finished 12:51:52 UTC   duration 161 s</a:t>
+            </a:r>
+          </a:p>
+          <a:p>
+            <a:pPr>
+              <a:spcAft>
+                <a:spcPts val="0"/>
+              </a:spcAft>
+            </a:pPr>
+            <a:r>
+              <a:rPr sz="1050">
+                <a:solidFill>
+                  <a:srgbClr val="1B3037"/>
+                </a:solidFill>
+                <a:latin typeface="Courier New"/>
+              </a:rPr>
+              <a:t> </a:t>
+            </a:r>
+          </a:p>
+          <a:p>
+            <a:pPr>
+              <a:spcAft>
+                <a:spcPts val="0"/>
+              </a:spcAft>
+            </a:pPr>
+            <a:r>
+              <a:rPr sz="1050">
+                <a:solidFill>
+                  <a:srgbClr val="1B3037"/>
+                </a:solidFill>
+                <a:latin typeface="Courier New"/>
+              </a:rPr>
+              <a:t>flow                        type               output_rows</a:t>
+            </a:r>
+          </a:p>
+          <a:p>
+            <a:pPr>
+              <a:spcAft>
+                <a:spcPts val="0"/>
+              </a:spcAft>
+            </a:pPr>
+            <a:r>
+              <a:rPr sz="1050">
+                <a:solidFill>
+                  <a:srgbClr val="1B3037"/>
+                </a:solidFill>
+                <a:latin typeface="Courier New"/>
+              </a:rPr>
+              <a:t>bronze_gauge_readings_ai    streaming table    30   &lt;- Auto Loader + ai_query: one model call per photo</a:t>
+            </a:r>
+          </a:p>
+          <a:p>
+            <a:pPr>
+              <a:spcAft>
+                <a:spcPts val="0"/>
+              </a:spcAft>
+            </a:pPr>
+            <a:r>
+              <a:rPr sz="1050">
+                <a:solidFill>
+                  <a:srgbClr val="1B3037"/>
+                </a:solidFill>
+                <a:latin typeface="Courier New"/>
+              </a:rPr>
+              <a:t>bronze_gauge_metadata       streaming table    30</a:t>
+            </a:r>
+          </a:p>
+          <a:p>
+            <a:pPr>
+              <a:spcAft>
+                <a:spcPts val="0"/>
+              </a:spcAft>
+            </a:pPr>
+            <a:r>
+              <a:rPr sz="1050">
+                <a:solidFill>
+                  <a:srgbClr val="1B3037"/>
+                </a:solidFill>
+                <a:latin typeface="Courier New"/>
+              </a:rPr>
+              <a:t>silver_gauge_readings       streaming table    30</a:t>
+            </a:r>
+          </a:p>
+          <a:p>
+            <a:pPr>
+              <a:spcAft>
+                <a:spcPts val="0"/>
+              </a:spcAft>
+            </a:pPr>
+            <a:r>
+              <a:rPr sz="1050">
+                <a:solidFill>
+                  <a:srgbClr val="1B3037"/>
+                </a:solidFill>
+                <a:latin typeface="Courier New"/>
+              </a:rPr>
+              <a:t>quarantine_vlm_errors       streaming table     0   &lt;- no failed model calls</a:t>
+            </a:r>
+          </a:p>
+          <a:p>
+            <a:pPr>
+              <a:spcAft>
+                <a:spcPts val="0"/>
+              </a:spcAft>
+            </a:pPr>
+            <a:r>
+              <a:rPr sz="1050">
+                <a:solidFill>
+                  <a:srgbClr val="1B3037"/>
+                </a:solidFill>
+                <a:latin typeface="Courier New"/>
+              </a:rPr>
+              <a:t>gold_gauge_readings_final   materialized view  30</a:t>
+            </a:r>
+          </a:p>
+          <a:p>
+            <a:pPr>
+              <a:spcAft>
+                <a:spcPts val="0"/>
+              </a:spcAft>
+            </a:pPr>
+            <a:r>
+              <a:rPr sz="1050">
+                <a:solidFill>
+                  <a:srgbClr val="1B3037"/>
+                </a:solidFill>
+                <a:latin typeface="Courier New"/>
+              </a:rPr>
+              <a:t>Later updates incl. the refresh job (cause JOB_TASK): bronze_gauge_readings_ai = 0 rows each time -&gt; no photo re-read</a:t>
+            </a:r>
+          </a:p>
+        </p:txBody>
+      </p:sp>
+      <p:sp>
+        <p:nvSpPr>
+          <p:cNvPr id="6" name="TextBox 5"/>
+          <p:cNvSpPr txBox="1"/>
+          <p:nvPr/>
+        </p:nvSpPr>
+        <p:spPr>
+          <a:xfrm>
+            <a:off x="758952" y="4434840"/>
+            <a:ext cx="5394960" cy="1737360"/>
+          </a:xfrm>
+          <a:prstGeom prst="rect">
+            <a:avLst/>
+          </a:prstGeom>
+          <a:noFill/>
+        </p:spPr>
+        <p:txBody>
+          <a:bodyPr wrap="square" anchor="t" lIns="36576" rIns="36576" tIns="36576" bIns="36576">
+            <a:spAutoFit/>
+          </a:bodyPr>
+          <a:lstStyle/>
+          <a:p>
+            <a:pPr>
+              <a:spcAft>
+                <a:spcPts val="400"/>
+              </a:spcAft>
+            </a:pPr>
+            <a:r>
+              <a:rPr sz="1300" b="1">
+                <a:solidFill>
+                  <a:srgbClr val="FF3621"/>
+                </a:solidFill>
+                <a:latin typeface="DM Sans"/>
+              </a:rPr>
+              <a:t>Data-quality expectations (event log)</a:t>
+            </a:r>
+          </a:p>
+          <a:p>
+            <a:pPr>
+              <a:spcAft>
+                <a:spcPts val="0"/>
+              </a:spcAft>
+            </a:pPr>
+            <a:r>
+              <a:rPr sz="1050">
+                <a:solidFill>
+                  <a:srgbClr val="1B3037"/>
+                </a:solidFill>
+                <a:latin typeface="Courier New"/>
+              </a:rPr>
+              <a:t>expectation            passed  failed</a:t>
+            </a:r>
+          </a:p>
+          <a:p>
+            <a:pPr>
+              <a:spcAft>
+                <a:spcPts val="0"/>
+              </a:spcAft>
+            </a:pPr>
+            <a:r>
+              <a:rPr sz="1050">
+                <a:solidFill>
+                  <a:srgbClr val="1B3037"/>
+                </a:solidFill>
+                <a:latin typeface="Courier New"/>
+              </a:rPr>
+              <a:t>vlm_call_succeeded       30      0</a:t>
+            </a:r>
+          </a:p>
+          <a:p>
+            <a:pPr>
+              <a:spcAft>
+                <a:spcPts val="0"/>
+              </a:spcAft>
+            </a:pPr>
+            <a:r>
+              <a:rPr sz="1050">
+                <a:solidFill>
+                  <a:srgbClr val="1B3037"/>
+                </a:solidFill>
+                <a:latin typeface="Courier New"/>
+              </a:rPr>
+              <a:t>response_parsed          30      0</a:t>
+            </a:r>
+          </a:p>
+          <a:p>
+            <a:pPr>
+              <a:spcAft>
+                <a:spcPts val="0"/>
+              </a:spcAft>
+            </a:pPr>
+            <a:r>
+              <a:rPr sz="1050">
+                <a:solidFill>
+                  <a:srgbClr val="1B3037"/>
+                </a:solidFill>
+                <a:latin typeface="Courier New"/>
+              </a:rPr>
+              <a:t>reading_within_scale     30      0</a:t>
+            </a:r>
+          </a:p>
+          <a:p>
+            <a:pPr>
+              <a:spcAft>
+                <a:spcPts val="0"/>
+              </a:spcAft>
+            </a:pPr>
+            <a:r>
+              <a:rPr sz="1050">
+                <a:solidFill>
+                  <a:srgbClr val="1B3037"/>
+                </a:solidFill>
+                <a:latin typeface="Courier New"/>
+              </a:rPr>
+              <a:t>unit_present             29      1  (warn, routed to review)</a:t>
+            </a:r>
+          </a:p>
+          <a:p>
+            <a:pPr>
+              <a:spcAft>
+                <a:spcPts val="0"/>
+              </a:spcAft>
+            </a:pPr>
+            <a:r>
+              <a:rPr sz="1050">
+                <a:solidFill>
+                  <a:srgbClr val="1B3037"/>
+                </a:solidFill>
+                <a:latin typeface="Courier New"/>
+              </a:rPr>
+              <a:t>gauge_id_present         30      0</a:t>
+            </a:r>
+          </a:p>
+        </p:txBody>
+      </p:sp>
+      <p:sp>
+        <p:nvSpPr>
+          <p:cNvPr id="7" name="TextBox 6"/>
+          <p:cNvSpPr txBox="1"/>
+          <p:nvPr/>
+        </p:nvSpPr>
+        <p:spPr>
+          <a:xfrm>
+            <a:off x="6309360" y="4434840"/>
+            <a:ext cx="5212080" cy="1737360"/>
+          </a:xfrm>
+          <a:prstGeom prst="rect">
+            <a:avLst/>
+          </a:prstGeom>
+          <a:noFill/>
+        </p:spPr>
+        <p:txBody>
+          <a:bodyPr wrap="square" anchor="t" lIns="36576" rIns="36576" tIns="36576" bIns="36576">
+            <a:spAutoFit/>
+          </a:bodyPr>
+          <a:lstStyle/>
+          <a:p>
+            <a:pPr>
+              <a:spcAft>
+                <a:spcPts val="400"/>
+              </a:spcAft>
+            </a:pPr>
+            <a:r>
+              <a:rPr sz="1300" b="1">
+                <a:solidFill>
+                  <a:srgbClr val="FF3621"/>
+                </a:solidFill>
+                <a:latin typeface="DM Sans"/>
+              </a:rPr>
+              <a:t>Unity AI Gateway (system.ai_gateway.usage)</a:t>
+            </a:r>
+          </a:p>
+          <a:p>
+            <a:pPr>
+              <a:spcAft>
+                <a:spcPts val="0"/>
+              </a:spcAft>
+            </a:pPr>
+            <a:r>
+              <a:rPr sz="1050">
+                <a:solidFill>
+                  <a:srgbClr val="1B3037"/>
+                </a:solidFill>
+                <a:latin typeface="Courier New"/>
+              </a:rPr>
+              <a:t>service   system.ai.gpt-5-5   source AI_QUERY</a:t>
+            </a:r>
+          </a:p>
+          <a:p>
+            <a:pPr>
+              <a:spcAft>
+                <a:spcPts val="0"/>
+              </a:spcAft>
+            </a:pPr>
+            <a:r>
+              <a:rPr sz="1050">
+                <a:solidFill>
+                  <a:srgbClr val="1B3037"/>
+                </a:solidFill>
+                <a:latin typeface="Courier New"/>
+              </a:rPr>
+              <a:t>requests  33 (30 photos + 3 test calls)</a:t>
+            </a:r>
+          </a:p>
+          <a:p>
+            <a:pPr>
+              <a:spcAft>
+                <a:spcPts val="0"/>
+              </a:spcAft>
+            </a:pPr>
+            <a:r>
+              <a:rPr sz="1050">
+                <a:solidFill>
+                  <a:srgbClr val="1B3037"/>
+                </a:solidFill>
+                <a:latin typeface="Courier New"/>
+              </a:rPr>
+              <a:t>errors    0</a:t>
+            </a:r>
+          </a:p>
+          <a:p>
+            <a:pPr>
+              <a:spcAft>
+                <a:spcPts val="0"/>
+              </a:spcAft>
+            </a:pPr>
+            <a:r>
+              <a:rPr sz="1050">
+                <a:solidFill>
+                  <a:srgbClr val="1B3037"/>
+                </a:solidFill>
+                <a:latin typeface="Courier New"/>
+              </a:rPr>
+              <a:t>tokens    65,063 in / 31,717 out</a:t>
+            </a:r>
+          </a:p>
+          <a:p>
+            <a:pPr>
+              <a:spcAft>
+                <a:spcPts val="0"/>
+              </a:spcAft>
+            </a:pPr>
+            <a:r>
+              <a:rPr sz="1050">
+                <a:solidFill>
+                  <a:srgbClr val="1B3037"/>
+                </a:solidFill>
+                <a:latin typeface="Courier New"/>
+              </a:rPr>
+              <a:t>cost      $1.2688 at list price</a:t>
+            </a:r>
+          </a:p>
+          <a:p>
+            <a:pPr>
+              <a:spcAft>
+                <a:spcPts val="0"/>
+              </a:spcAft>
+            </a:pPr>
+            <a:r>
+              <a:rPr sz="1050">
+                <a:solidFill>
+                  <a:srgbClr val="1B3037"/>
+                </a:solidFill>
+                <a:latin typeface="Courier New"/>
+              </a:rPr>
+              <a:t>          = $0.0423 per photo</a:t>
+            </a:r>
+          </a:p>
+        </p:txBody>
+      </p:sp>
+      <p:sp>
+        <p:nvSpPr>
+          <p:cNvPr id="8" name="TextBox 7"/>
+          <p:cNvSpPr txBox="1"/>
+          <p:nvPr/>
+        </p:nvSpPr>
+        <p:spPr>
+          <a:xfrm>
+            <a:off x="758952" y="6199632"/>
+            <a:ext cx="10661904" cy="274320"/>
+          </a:xfrm>
+          <a:prstGeom prst="rect">
+            <a:avLst/>
+          </a:prstGeom>
+          <a:noFill/>
+        </p:spPr>
+        <p:txBody>
+          <a:bodyPr wrap="square" anchor="t" lIns="45720" rIns="45720">
+            <a:spAutoFit/>
+          </a:bodyPr>
+          <a:lstStyle/>
+          <a:p>
+            <a:pPr algn="l"/>
+            <a:r>
+              <a:rPr sz="900" b="0">
+                <a:solidFill>
+                  <a:srgbClr val="5F6B70"/>
+                </a:solidFill>
+                <a:latin typeface="DM Sans"/>
+              </a:rPr>
+              <a:t>Captured 2026-10-07 15:34 UTC from the build workspace by src/setup/capture_evidence.py · full output in evidence/ (index: VALIDATION.md)</a:t>
+            </a:r>
+          </a:p>
+        </p:txBody>
+      </p:sp>
+    </p:spTree>
+  </p:cSld>
+  <p:clrMapOvr>
+    <a:masterClrMapping/>
+  </p:clrMapOvr>
+</p:sld>
+</file>
+
+<file path=ppt/slides/slide13.xml><?xml version="1.0" encoding="utf-8"?>
+<p:sld xmlns:a="http://schemas.openxmlformats.org/drawingml/2006/main" xmlns:p="http://schemas.openxmlformats.org/presentationml/2006/main" xmlns:r="http://schemas.openxmlformats.org/officeDocument/2006/relationships">
+  <p:cSld>
+    <p:spTree>
+      <p:nvGrpSpPr>
+        <p:cNvPr id="1" name=""/>
+        <p:cNvGrpSpPr/>
+        <p:nvPr/>
+      </p:nvGrpSpPr>
+      <p:grpSpPr/>
+      <p:sp>
+        <p:nvSpPr>
+          <p:cNvPr id="2" name="Title 1"/>
+          <p:cNvSpPr>
+            <a:spLocks noGrp="1"/>
+          </p:cNvSpPr>
+          <p:nvPr>
+            <p:ph type="title"/>
+          </p:nvPr>
+        </p:nvSpPr>
+        <p:spPr/>
+        <p:txBody>
+          <a:bodyPr/>
+          <a:lstStyle/>
+          <a:p>
+            <a:r>
+              <a:t>Appendix B · Governance and serving</a:t>
+            </a:r>
+          </a:p>
+        </p:txBody>
+      </p:sp>
+      <p:sp>
+        <p:nvSpPr>
+          <p:cNvPr id="4" name="Text Placeholder 3"/>
+          <p:cNvSpPr>
+            <a:spLocks noGrp="1"/>
+          </p:cNvSpPr>
+          <p:nvPr>
+            <p:ph type="body" idx="2"/>
+          </p:nvPr>
+        </p:nvSpPr>
+        <p:spPr/>
+        <p:txBody>
+          <a:bodyPr/>
+          <a:lstStyle/>
+          <a:p>
+            <a:r>
+              <a:t>Evidence: Unity Catalog grants and Lakebase query results</a:t>
+            </a:r>
+          </a:p>
+        </p:txBody>
+      </p:sp>
+      <p:sp>
+        <p:nvSpPr>
+          <p:cNvPr id="5" name="TextBox 4"/>
+          <p:cNvSpPr txBox="1"/>
+          <p:nvPr/>
+        </p:nvSpPr>
+        <p:spPr>
+          <a:xfrm>
+            <a:off x="758952" y="1783080"/>
+            <a:ext cx="10698480" cy="1783080"/>
+          </a:xfrm>
+          <a:prstGeom prst="rect">
+            <a:avLst/>
+          </a:prstGeom>
+          <a:noFill/>
+        </p:spPr>
+        <p:txBody>
+          <a:bodyPr wrap="square" anchor="t" lIns="36576" rIns="36576" tIns="36576" bIns="36576">
+            <a:spAutoFit/>
+          </a:bodyPr>
+          <a:lstStyle/>
+          <a:p>
+            <a:pPr>
+              <a:spcAft>
+                <a:spcPts val="400"/>
+              </a:spcAft>
+            </a:pPr>
+            <a:r>
+              <a:rPr sz="1300" b="1">
+                <a:solidFill>
+                  <a:srgbClr val="FF3621"/>
+                </a:solidFill>
+                <a:latin typeface="DM Sans"/>
+              </a:rPr>
+              <a:t>Unity Catalog: SHOW GRANTS and system.access.table_lineage</a:t>
+            </a:r>
+          </a:p>
+          <a:p>
+            <a:pPr>
+              <a:spcAft>
+                <a:spcPts val="0"/>
+              </a:spcAft>
+            </a:pPr>
+            <a:r>
+              <a:rPr sz="1050">
+                <a:solidFill>
+                  <a:srgbClr val="1B3037"/>
+                </a:solidFill>
+                <a:latin typeface="Courier New"/>
+              </a:rPr>
+              <a:t>gold_gauge_readings_final   account users          SELECT        (analysts: gold only)</a:t>
+            </a:r>
+          </a:p>
+          <a:p>
+            <a:pPr>
+              <a:spcAft>
+                <a:spcPts val="0"/>
+              </a:spcAft>
+            </a:pPr>
+            <a:r>
+              <a:rPr sz="1050">
+                <a:solidFill>
+                  <a:srgbClr val="1B3037"/>
+                </a:solidFill>
+                <a:latin typeface="Courier New"/>
+              </a:rPr>
+              <a:t>raw (volume)                app service principal  READ VOLUME   (photos read-only)</a:t>
+            </a:r>
+          </a:p>
+          <a:p>
+            <a:pPr>
+              <a:spcAft>
+                <a:spcPts val="0"/>
+              </a:spcAft>
+            </a:pPr>
+            <a:r>
+              <a:rPr sz="1050">
+                <a:solidFill>
+                  <a:srgbClr val="1B3037"/>
+                </a:solidFill>
+                <a:latin typeface="Courier New"/>
+              </a:rPr>
+              <a:t>bronze_gauge_readings_ai    no grants to analysts or the app</a:t>
+            </a:r>
+          </a:p>
+          <a:p>
+            <a:pPr>
+              <a:spcAft>
+                <a:spcPts val="0"/>
+              </a:spcAft>
+            </a:pPr>
+            <a:r>
+              <a:rPr sz="1050">
+                <a:solidFill>
+                  <a:srgbClr val="1B3037"/>
+                </a:solidFill>
+                <a:latin typeface="Courier New"/>
+              </a:rPr>
+              <a:t>system.ai model services    account users          EXECUTE</a:t>
+            </a:r>
+          </a:p>
+          <a:p>
+            <a:pPr>
+              <a:spcAft>
+                <a:spcPts val="0"/>
+              </a:spcAft>
+            </a:pPr>
+            <a:r>
+              <a:rPr sz="1050">
+                <a:solidFill>
+                  <a:srgbClr val="1B3037"/>
+                </a:solidFill>
+                <a:latin typeface="Courier New"/>
+              </a:rPr>
+              <a:t>lineage: files -&gt; bronze -&gt; silver -&gt; gold;  lb_reading_overrides_history (Lakebase decisions) -&gt; gold</a:t>
+            </a:r>
+          </a:p>
+        </p:txBody>
+      </p:sp>
+      <p:sp>
+        <p:nvSpPr>
+          <p:cNvPr id="6" name="TextBox 5"/>
+          <p:cNvSpPr txBox="1"/>
+          <p:nvPr/>
+        </p:nvSpPr>
+        <p:spPr>
+          <a:xfrm>
+            <a:off x="758952" y="3429000"/>
+            <a:ext cx="10698480" cy="2697480"/>
+          </a:xfrm>
+          <a:prstGeom prst="rect">
+            <a:avLst/>
+          </a:prstGeom>
+          <a:noFill/>
+        </p:spPr>
+        <p:txBody>
+          <a:bodyPr wrap="square" anchor="t" lIns="36576" rIns="36576" tIns="36576" bIns="36576">
+            <a:spAutoFit/>
+          </a:bodyPr>
+          <a:lstStyle/>
+          <a:p>
+            <a:pPr>
+              <a:spcAft>
+                <a:spcPts val="400"/>
+              </a:spcAft>
+            </a:pPr>
+            <a:r>
+              <a:rPr sz="1300" b="1">
+                <a:solidFill>
+                  <a:srgbClr val="FF3621"/>
+                </a:solidFill>
+                <a:latin typeface="DM Sans"/>
+              </a:rPr>
+              <a:t>Lakebase: query on pressure_gauge.gauge_readings_serving (what the app reads)</a:t>
+            </a:r>
+          </a:p>
+          <a:p>
+            <a:pPr>
+              <a:spcAft>
+                <a:spcPts val="0"/>
+              </a:spcAft>
+            </a:pPr>
+            <a:r>
+              <a:rPr sz="1050">
+                <a:solidFill>
+                  <a:srgbClr val="1B3037"/>
+                </a:solidFill>
+                <a:latin typeface="Courier New"/>
+              </a:rPr>
+              <a:t> rows | needs_review | unexpectedly_high | human_corrected</a:t>
+            </a:r>
+          </a:p>
+          <a:p>
+            <a:pPr>
+              <a:spcAft>
+                <a:spcPts val="0"/>
+              </a:spcAft>
+            </a:pPr>
+            <a:r>
+              <a:rPr sz="1050">
+                <a:solidFill>
+                  <a:srgbClr val="1B3037"/>
+                </a:solidFill>
+                <a:latin typeface="Courier New"/>
+              </a:rPr>
+              <a:t>   30 |            9 |                 4 |               1</a:t>
+            </a:r>
+          </a:p>
+          <a:p>
+            <a:pPr>
+              <a:spcAft>
+                <a:spcPts val="0"/>
+              </a:spcAft>
+            </a:pPr>
+            <a:r>
+              <a:rPr sz="1050">
+                <a:solidFill>
+                  <a:srgbClr val="1B3037"/>
+                </a:solidFill>
+                <a:latin typeface="Courier New"/>
+              </a:rPr>
+              <a:t> </a:t>
+            </a:r>
+          </a:p>
+          <a:p>
+            <a:pPr>
+              <a:spcAft>
+                <a:spcPts val="0"/>
+              </a:spcAft>
+            </a:pPr>
+            <a:r>
+              <a:rPr sz="1050">
+                <a:solidFill>
+                  <a:srgbClr val="1B3037"/>
+                </a:solidFill>
+                <a:latin typeface="Courier New"/>
+              </a:rPr>
+              <a:t> image_id      | gauge_id | site              | value | unit    | confidence | reading_status | review_status</a:t>
+            </a:r>
+          </a:p>
+          <a:p>
+            <a:pPr>
+              <a:spcAft>
+                <a:spcPts val="0"/>
+              </a:spcAft>
+            </a:pPr>
+            <a:r>
+              <a:rPr sz="1050">
+                <a:solidFill>
+                  <a:srgbClr val="1B3037"/>
+                </a:solidFill>
+                <a:latin typeface="Courier New"/>
+              </a:rPr>
+              <a:t> gauge_004.jpg | PI-1101  | Northbay Refinery |       | unknown |       0.00 | unreadable     | pending_review</a:t>
+            </a:r>
+          </a:p>
+          <a:p>
+            <a:pPr>
+              <a:spcAft>
+                <a:spcPts val="0"/>
+              </a:spcAft>
+            </a:pPr>
+            <a:r>
+              <a:rPr sz="1050">
+                <a:solidFill>
+                  <a:srgbClr val="1B3037"/>
+                </a:solidFill>
+                <a:latin typeface="Courier New"/>
+              </a:rPr>
+              <a:t> gauge_003.jpg | PI-6102  | Ridgeway Terminal |   190 | psi     |       0.42 | normal         | pending_review</a:t>
+            </a:r>
+          </a:p>
+          <a:p>
+            <a:pPr>
+              <a:spcAft>
+                <a:spcPts val="0"/>
+              </a:spcAft>
+            </a:pPr>
+            <a:r>
+              <a:rPr sz="1050">
+                <a:solidFill>
+                  <a:srgbClr val="1B3037"/>
+                </a:solidFill>
+                <a:latin typeface="Courier New"/>
+              </a:rPr>
+              <a:t> gauge_030.jpg | PI-4108  | Northbay Refinery |   620 | kPa     |       0.62 | high           | pending_review</a:t>
+            </a:r>
+          </a:p>
+          <a:p>
+            <a:pPr>
+              <a:spcAft>
+                <a:spcPts val="0"/>
+              </a:spcAft>
+            </a:pPr>
+            <a:r>
+              <a:rPr sz="1050">
+                <a:solidFill>
+                  <a:srgbClr val="1B3037"/>
+                </a:solidFill>
+                <a:latin typeface="Courier New"/>
+              </a:rPr>
+              <a:t> gauge_013.jpg | PI-3103  | Northbay Refinery |   187 | psi     |       0.86 | high           | pending_review</a:t>
+            </a:r>
+          </a:p>
+        </p:txBody>
+      </p:sp>
+      <p:sp>
+        <p:nvSpPr>
+          <p:cNvPr id="7" name="TextBox 6"/>
+          <p:cNvSpPr txBox="1"/>
+          <p:nvPr/>
+        </p:nvSpPr>
+        <p:spPr>
+          <a:xfrm>
+            <a:off x="758952" y="6199632"/>
+            <a:ext cx="10661904" cy="274320"/>
+          </a:xfrm>
+          <a:prstGeom prst="rect">
+            <a:avLst/>
+          </a:prstGeom>
+          <a:noFill/>
+        </p:spPr>
+        <p:txBody>
+          <a:bodyPr wrap="square" anchor="t" lIns="45720" rIns="45720">
+            <a:spAutoFit/>
+          </a:bodyPr>
+          <a:lstStyle/>
+          <a:p>
+            <a:pPr algn="l"/>
+            <a:r>
+              <a:rPr sz="900" b="0">
+                <a:solidFill>
+                  <a:srgbClr val="5F6B70"/>
+                </a:solidFill>
+                <a:latin typeface="DM Sans"/>
+              </a:rPr>
+              <a:t>Captured 2026-10-07 15:34 UTC from the build workspace by src/setup/capture_evidence.py · full output in evidence/ (index: VALIDATION.md)</a:t>
+            </a:r>
+          </a:p>
+        </p:txBody>
+      </p:sp>
+    </p:spTree>
+  </p:cSld>
+  <p:clrMapOvr>
+    <a:masterClrMapping/>
+  </p:clrMapOvr>
+</p:sld>
+</file>
+
+<file path=ppt/slides/slide14.xml><?xml version="1.0" encoding="utf-8"?>
+<p:sld xmlns:a="http://schemas.openxmlformats.org/drawingml/2006/main" xmlns:p="http://schemas.openxmlformats.org/presentationml/2006/main" xmlns:r="http://schemas.openxmlformats.org/officeDocument/2006/relationships">
+  <p:cSld>
+    <p:spTree>
+      <p:nvGrpSpPr>
+        <p:cNvPr id="1" name=""/>
+        <p:cNvGrpSpPr/>
+        <p:nvPr/>
+      </p:nvGrpSpPr>
+      <p:grpSpPr/>
+      <p:sp>
+        <p:nvSpPr>
+          <p:cNvPr id="2" name="Title 1"/>
+          <p:cNvSpPr>
+            <a:spLocks noGrp="1"/>
+          </p:cNvSpPr>
+          <p:nvPr>
+            <p:ph type="title"/>
+          </p:nvPr>
+        </p:nvSpPr>
+        <p:spPr/>
+        <p:txBody>
+          <a:bodyPr/>
+          <a:lstStyle/>
+          <a:p>
+            <a:r>
+              <a:t>Appendix C · Write-back and the app</a:t>
+            </a:r>
+          </a:p>
+        </p:txBody>
+      </p:sp>
+      <p:sp>
+        <p:nvSpPr>
+          <p:cNvPr id="4" name="Text Placeholder 3"/>
+          <p:cNvSpPr>
+            <a:spLocks noGrp="1"/>
+          </p:cNvSpPr>
+          <p:nvPr>
+            <p:ph type="body" idx="2"/>
+          </p:nvPr>
+        </p:nvSpPr>
+        <p:spPr/>
+        <p:txBody>
+          <a:bodyPr/>
+          <a:lstStyle/>
+          <a:p>
+            <a:r>
+              <a:t>Evidence: one human correction end to end; the deployed app's live API</a:t>
+            </a:r>
+          </a:p>
+        </p:txBody>
+      </p:sp>
+      <p:sp>
+        <p:nvSpPr>
+          <p:cNvPr id="5" name="TextBox 4"/>
+          <p:cNvSpPr txBox="1"/>
+          <p:nvPr/>
+        </p:nvSpPr>
+        <p:spPr>
+          <a:xfrm>
+            <a:off x="758952" y="1783080"/>
+            <a:ext cx="10698480" cy="2011680"/>
+          </a:xfrm>
+          <a:prstGeom prst="rect">
+            <a:avLst/>
+          </a:prstGeom>
+          <a:noFill/>
+        </p:spPr>
+        <p:txBody>
+          <a:bodyPr wrap="square" anchor="t" lIns="36576" rIns="36576" tIns="36576" bIns="36576">
+            <a:spAutoFit/>
+          </a:bodyPr>
+          <a:lstStyle/>
+          <a:p>
+            <a:pPr>
+              <a:spcAft>
+                <a:spcPts val="400"/>
+              </a:spcAft>
+            </a:pPr>
+            <a:r>
+              <a:rPr sz="1300" b="1">
+                <a:solidFill>
+                  <a:srgbClr val="FF3621"/>
+                </a:solidFill>
+                <a:latin typeface="DM Sans"/>
+              </a:rPr>
+              <a:t>Correction round trip: app -&gt; Lakebase -&gt; Delta -&gt; gold -&gt; Lakebase</a:t>
+            </a:r>
+          </a:p>
+          <a:p>
+            <a:pPr>
+              <a:spcAft>
+                <a:spcPts val="0"/>
+              </a:spcAft>
+            </a:pPr>
+            <a:r>
+              <a:rPr sz="1050">
+                <a:solidFill>
+                  <a:srgbClr val="1B3037"/>
+                </a:solidFill>
+                <a:latin typeface="Courier New"/>
+              </a:rPr>
+              <a:t>1 review.reading_overrides (Lakebase)   id 2 | gauge_009.jpg | override | human_value 1 | 2026-10-06 13:28:01 UTC</a:t>
+            </a:r>
+          </a:p>
+          <a:p>
+            <a:pPr>
+              <a:spcAft>
+                <a:spcPts val="0"/>
+              </a:spcAft>
+            </a:pPr>
+            <a:r>
+              <a:rPr sz="1050">
+                <a:solidFill>
+                  <a:srgbClr val="1B3037"/>
+                </a:solidFill>
+                <a:latin typeface="Courier New"/>
+              </a:rPr>
+              <a:t>  reason: "Read the wrong scale: needle tip is at ~1.0 bar; the AI read the counterweight end"</a:t>
+            </a:r>
+          </a:p>
+          <a:p>
+            <a:pPr>
+              <a:spcAft>
+                <a:spcPts val="0"/>
+              </a:spcAft>
+            </a:pPr>
+            <a:r>
+              <a:rPr sz="1050">
+                <a:solidFill>
+                  <a:srgbClr val="1B3037"/>
+                </a:solidFill>
+                <a:latin typeface="Courier New"/>
+              </a:rPr>
+              <a:t>2 Lakehouse Sync -&gt; Delta history       insert | _pg_lsn 30799832 | 2026-10-06T13:28:01.399</a:t>
+            </a:r>
+          </a:p>
+          <a:p>
+            <a:pPr>
+              <a:spcAft>
+                <a:spcPts val="0"/>
+              </a:spcAft>
+            </a:pPr>
+            <a:r>
+              <a:rPr sz="1050">
+                <a:solidFill>
+                  <a:srgbClr val="1B3037"/>
+                </a:solidFill>
+                <a:latin typeface="Courier New"/>
+              </a:rPr>
+              <a:t>3 Pipeline (job run) -&gt; gold            PI-3102 | ai_value 5.0 | final_value 1.0 bar | overridden | is_human_corrected true</a:t>
+            </a:r>
+          </a:p>
+          <a:p>
+            <a:pPr>
+              <a:spcAft>
+                <a:spcPts val="0"/>
+              </a:spcAft>
+            </a:pPr>
+            <a:r>
+              <a:rPr sz="1050">
+                <a:solidFill>
+                  <a:srgbClr val="1B3037"/>
+                </a:solidFill>
+                <a:latin typeface="Courier New"/>
+              </a:rPr>
+              <a:t>4 Snapshot sync -&gt; serving table        gauge_009.jpg | ai_value 5 | final_value 1 | overridden</a:t>
+            </a:r>
+          </a:p>
+        </p:txBody>
+      </p:sp>
+      <p:sp>
+        <p:nvSpPr>
+          <p:cNvPr id="6" name="TextBox 5"/>
+          <p:cNvSpPr txBox="1"/>
+          <p:nvPr/>
+        </p:nvSpPr>
+        <p:spPr>
+          <a:xfrm>
+            <a:off x="758952" y="3840480"/>
+            <a:ext cx="10698480" cy="2286000"/>
+          </a:xfrm>
+          <a:prstGeom prst="rect">
+            <a:avLst/>
+          </a:prstGeom>
+          <a:noFill/>
+        </p:spPr>
+        <p:txBody>
+          <a:bodyPr wrap="square" anchor="t" lIns="36576" rIns="36576" tIns="36576" bIns="36576">
+            <a:spAutoFit/>
+          </a:bodyPr>
+          <a:lstStyle/>
+          <a:p>
+            <a:pPr>
+              <a:spcAft>
+                <a:spcPts val="400"/>
+              </a:spcAft>
+            </a:pPr>
+            <a:r>
+              <a:rPr sz="1300" b="1">
+                <a:solidFill>
+                  <a:srgbClr val="FF3621"/>
+                </a:solidFill>
+                <a:latin typeface="DM Sans"/>
+              </a:rPr>
+              <a:t>Deployed Databricks App: live API responses</a:t>
+            </a:r>
+          </a:p>
+          <a:p>
+            <a:pPr>
+              <a:spcAft>
+                <a:spcPts val="0"/>
+              </a:spcAft>
+            </a:pPr>
+            <a:r>
+              <a:rPr sz="1050">
+                <a:solidFill>
+                  <a:srgbClr val="1B3037"/>
+                </a:solidFill>
+                <a:latin typeface="Courier New"/>
+              </a:rPr>
+              <a:t>GET /api/readings      -&gt; HTTP 200   30 readings · reviewConfidenceThreshold 0.7</a:t>
+            </a:r>
+          </a:p>
+          <a:p>
+            <a:pPr>
+              <a:spcAft>
+                <a:spcPts val="0"/>
+              </a:spcAft>
+            </a:pPr>
+            <a:r>
+              <a:rPr sz="1050">
+                <a:solidFill>
+                  <a:srgbClr val="1B3037"/>
+                </a:solidFill>
+                <a:latin typeface="Courier New"/>
+              </a:rPr>
+              <a:t>  { "gauge_id": "PI-3102", "ai_value": 5, "final_value": 1, "unit": "bar", "vlm_confidence": 0.86,</a:t>
+            </a:r>
+          </a:p>
+          <a:p>
+            <a:pPr>
+              <a:spcAft>
+                <a:spcPts val="0"/>
+              </a:spcAft>
+            </a:pPr>
+            <a:r>
+              <a:rPr sz="1050">
+                <a:solidFill>
+                  <a:srgbClr val="1B3037"/>
+                </a:solidFill>
+                <a:latin typeface="Courier New"/>
+              </a:rPr>
+              <a:t>    "review_status": "overridden", "override_reason": "Read the wrong scale: needle tip is at ~1.0 bar ..." }</a:t>
+            </a:r>
+          </a:p>
+          <a:p>
+            <a:pPr>
+              <a:spcAft>
+                <a:spcPts val="0"/>
+              </a:spcAft>
+            </a:pPr>
+            <a:r>
+              <a:rPr sz="1050">
+                <a:solidFill>
+                  <a:srgbClr val="1B3037"/>
+                </a:solidFill>
+                <a:latin typeface="Courier New"/>
+              </a:rPr>
+              <a:t>GET /api/model-usage   -&gt; HTTP 200   { "requests": "33", "images_read": "30", "errors": "0", "est_cost_usd": 1.2688 }</a:t>
+            </a:r>
+          </a:p>
+          <a:p>
+            <a:pPr>
+              <a:spcAft>
+                <a:spcPts val="0"/>
+              </a:spcAft>
+            </a:pPr>
+            <a:r>
+              <a:rPr sz="1050">
+                <a:solidFill>
+                  <a:srgbClr val="1B3037"/>
+                </a:solidFill>
+                <a:latin typeface="Courier New"/>
+              </a:rPr>
+              <a:t>GET /api/review-stats  -&gt; HTTP 200   { "decisions": 1, "images_reviewed": 1 }</a:t>
+            </a:r>
+          </a:p>
+        </p:txBody>
+      </p:sp>
+      <p:sp>
+        <p:nvSpPr>
+          <p:cNvPr id="7" name="TextBox 6"/>
+          <p:cNvSpPr txBox="1"/>
+          <p:nvPr/>
+        </p:nvSpPr>
+        <p:spPr>
+          <a:xfrm>
+            <a:off x="758952" y="6199632"/>
+            <a:ext cx="10661904" cy="274320"/>
+          </a:xfrm>
+          <a:prstGeom prst="rect">
+            <a:avLst/>
+          </a:prstGeom>
+          <a:noFill/>
+        </p:spPr>
+        <p:txBody>
+          <a:bodyPr wrap="square" anchor="t" lIns="45720" rIns="45720">
+            <a:spAutoFit/>
+          </a:bodyPr>
+          <a:lstStyle/>
+          <a:p>
+            <a:pPr algn="l"/>
+            <a:r>
+              <a:rPr sz="900" b="0">
+                <a:solidFill>
+                  <a:srgbClr val="5F6B70"/>
+                </a:solidFill>
+                <a:latin typeface="DM Sans"/>
+              </a:rPr>
+              <a:t>Captured 2026-10-07 15:34 UTC from the build workspace by src/setup/capture_evidence.py · full output in evidence/ (index: VALIDATION.md)</a:t>
+            </a:r>
+          </a:p>
+        </p:txBody>
+      </p:sp>
+    </p:spTree>
+  </p:cSld>
+  <p:clrMapOvr>
+    <a:masterClrMapping/>
+  </p:clrMapOvr>
+</p:sld>
+</file>
+
+<file path=ppt/slides/slide15.xml><?xml version="1.0" encoding="utf-8"?>
+<p:sld xmlns:a="http://schemas.openxmlformats.org/drawingml/2006/main" xmlns:p="http://schemas.openxmlformats.org/presentationml/2006/main" xmlns:r="http://schemas.openxmlformats.org/officeDocument/2006/relationships">
+  <p:cSld>
+    <p:spTree>
+      <p:nvGrpSpPr>
+        <p:cNvPr id="1" name=""/>
+        <p:cNvGrpSpPr/>
+        <p:nvPr/>
+      </p:nvGrpSpPr>
+      <p:grpSpPr/>
+      <p:sp>
+        <p:nvSpPr>
+          <p:cNvPr id="2" name="Title 1"/>
+          <p:cNvSpPr>
+            <a:spLocks noGrp="1"/>
+          </p:cNvSpPr>
+          <p:nvPr>
+            <p:ph type="title"/>
+          </p:nvPr>
+        </p:nvSpPr>
+        <p:spPr/>
+        <p:txBody>
+          <a:bodyPr/>
+          <a:lstStyle/>
+          <a:p>
+            <a:r>
+              <a:t>Appendix D · Genie Agent</a:t>
+            </a:r>
+          </a:p>
+        </p:txBody>
+      </p:sp>
+      <p:sp>
+        <p:nvSpPr>
+          <p:cNvPr id="4" name="Text Placeholder 3"/>
+          <p:cNvSpPr>
+            <a:spLocks noGrp="1"/>
+          </p:cNvSpPr>
+          <p:nvPr>
+            <p:ph type="body" idx="2"/>
+          </p:nvPr>
+        </p:nvSpPr>
+        <p:spPr/>
+        <p:txBody>
+          <a:bodyPr/>
+          <a:lstStyle/>
+          <a:p>
+            <a:r>
+              <a:t>Evidence: Genie's generated SQL and answers</a:t>
+            </a:r>
+          </a:p>
+        </p:txBody>
+      </p:sp>
+      <p:sp>
+        <p:nvSpPr>
+          <p:cNvPr id="5" name="TextBox 4"/>
+          <p:cNvSpPr txBox="1"/>
+          <p:nvPr/>
+        </p:nvSpPr>
+        <p:spPr>
+          <a:xfrm>
+            <a:off x="758952" y="1783080"/>
+            <a:ext cx="10698480" cy="2651760"/>
+          </a:xfrm>
+          <a:prstGeom prst="rect">
+            <a:avLst/>
+          </a:prstGeom>
+          <a:noFill/>
+        </p:spPr>
+        <p:txBody>
+          <a:bodyPr wrap="square" anchor="t" lIns="36576" rIns="36576" tIns="36576" bIns="36576">
+            <a:spAutoFit/>
+          </a:bodyPr>
+          <a:lstStyle/>
+          <a:p>
+            <a:pPr>
+              <a:spcAft>
+                <a:spcPts val="400"/>
+              </a:spcAft>
+            </a:pPr>
+            <a:r>
+              <a:rPr sz="1300" b="1">
+                <a:solidFill>
+                  <a:srgbClr val="FF3621"/>
+                </a:solidFill>
+                <a:latin typeface="DM Sans"/>
+              </a:rPr>
+              <a:t>Q: Are any pressure readings unusually high?</a:t>
+            </a:r>
+          </a:p>
+          <a:p>
+            <a:pPr>
+              <a:spcAft>
+                <a:spcPts val="0"/>
+              </a:spcAft>
+            </a:pPr>
+            <a:r>
+              <a:rPr sz="1000">
+                <a:solidFill>
+                  <a:srgbClr val="1B3037"/>
+                </a:solidFill>
+                <a:latin typeface="Courier New"/>
+              </a:rPr>
+              <a:t>SELECT captured_at, image_id, gauge_id, site, unit_area, final_value, unit, normal_max,</a:t>
+            </a:r>
+          </a:p>
+          <a:p>
+            <a:pPr>
+              <a:spcAft>
+                <a:spcPts val="0"/>
+              </a:spcAft>
+            </a:pPr>
+            <a:r>
+              <a:rPr sz="1000">
+                <a:solidFill>
+                  <a:srgbClr val="1B3037"/>
+                </a:solidFill>
+                <a:latin typeface="Courier New"/>
+              </a:rPr>
+              <a:t>       (final_value - normal_max) AS above_normal_max</a:t>
+            </a:r>
+          </a:p>
+          <a:p>
+            <a:pPr>
+              <a:spcAft>
+                <a:spcPts val="0"/>
+              </a:spcAft>
+            </a:pPr>
+            <a:r>
+              <a:rPr sz="1000">
+                <a:solidFill>
+                  <a:srgbClr val="1B3037"/>
+                </a:solidFill>
+                <a:latin typeface="Courier New"/>
+              </a:rPr>
+              <a:t>FROM serverless_stable_kx6lwb_catalog.pressure_gauge.gold_gauge_readings_final</a:t>
+            </a:r>
+          </a:p>
+          <a:p>
+            <a:pPr>
+              <a:spcAft>
+                <a:spcPts val="0"/>
+              </a:spcAft>
+            </a:pPr>
+            <a:r>
+              <a:rPr sz="1000">
+                <a:solidFill>
+                  <a:srgbClr val="1B3037"/>
+                </a:solidFill>
+                <a:latin typeface="Courier New"/>
+              </a:rPr>
+              <a:t>WHERE reading_status = 'high' AND final_value IS NOT NULL AND normal_max IS NOT NULL</a:t>
+            </a:r>
+          </a:p>
+          <a:p>
+            <a:pPr>
+              <a:spcAft>
+                <a:spcPts val="0"/>
+              </a:spcAft>
+            </a:pPr>
+            <a:r>
+              <a:rPr sz="1000">
+                <a:solidFill>
+                  <a:srgbClr val="1B3037"/>
+                </a:solidFill>
+                <a:latin typeface="Courier New"/>
+              </a:rPr>
+              <a:t>ORDER BY above_normal_max DESC</a:t>
+            </a:r>
+          </a:p>
+          <a:p>
+            <a:pPr>
+              <a:spcAft>
+                <a:spcPts val="0"/>
+              </a:spcAft>
+            </a:pPr>
+            <a:r>
+              <a:rPr sz="1000">
+                <a:solidFill>
+                  <a:srgbClr val="1B3037"/>
+                </a:solidFill>
+                <a:latin typeface="Courier New"/>
+              </a:rPr>
+              <a:t> </a:t>
+            </a:r>
+          </a:p>
+          <a:p>
+            <a:pPr>
+              <a:spcAft>
+                <a:spcPts val="0"/>
+              </a:spcAft>
+            </a:pPr>
+            <a:r>
+              <a:rPr sz="1000">
+                <a:solidFill>
+                  <a:srgbClr val="1B3037"/>
+                </a:solidFill>
+                <a:latin typeface="Courier New"/>
+              </a:rPr>
+              <a:t>PI-3103 | Steam &amp; Utilities | 187.0 psi | max 175.0 | +12.0      PI-4108 | Instrument Air | 620.0 kPa | max 615.0  | +5.0</a:t>
+            </a:r>
+          </a:p>
+          <a:p>
+            <a:pPr>
+              <a:spcAft>
+                <a:spcPts val="0"/>
+              </a:spcAft>
+            </a:pPr>
+            <a:r>
+              <a:rPr sz="1000">
+                <a:solidFill>
+                  <a:srgbClr val="1B3037"/>
+                </a:solidFill>
+                <a:latin typeface="Courier New"/>
+              </a:rPr>
+              <a:t>PI-3104 | Steam &amp; Utilities |  68.0 psi | max 60.0  | +8.0       PI-2101 | Hydrotreater   |  20.0 bar | max 18.75  | +1.25</a:t>
+            </a:r>
+          </a:p>
+          <a:p>
+            <a:pPr>
+              <a:spcAft>
+                <a:spcPts val="0"/>
+              </a:spcAft>
+            </a:pPr>
+            <a:r>
+              <a:rPr sz="1000">
+                <a:solidFill>
+                  <a:srgbClr val="1B3037"/>
+                </a:solidFill>
+                <a:latin typeface="Courier New"/>
+              </a:rPr>
+              <a:t>Answer: "Yes - 4 pressure readings are above their normal maximums ... the largest excursion is PI-3103." </a:t>
+            </a:r>
+          </a:p>
+        </p:txBody>
+      </p:sp>
+      <p:sp>
+        <p:nvSpPr>
+          <p:cNvPr id="6" name="TextBox 5"/>
+          <p:cNvSpPr txBox="1"/>
+          <p:nvPr/>
+        </p:nvSpPr>
+        <p:spPr>
+          <a:xfrm>
+            <a:off x="758952" y="4343400"/>
+            <a:ext cx="10698480" cy="1783080"/>
+          </a:xfrm>
+          <a:prstGeom prst="rect">
+            <a:avLst/>
+          </a:prstGeom>
+          <a:noFill/>
+        </p:spPr>
+        <p:txBody>
+          <a:bodyPr wrap="square" anchor="t" lIns="36576" rIns="36576" tIns="36576" bIns="36576">
+            <a:spAutoFit/>
+          </a:bodyPr>
+          <a:lstStyle/>
+          <a:p>
+            <a:pPr>
+              <a:spcAft>
+                <a:spcPts val="400"/>
+              </a:spcAft>
+            </a:pPr>
+            <a:r>
+              <a:rPr sz="1300" b="1">
+                <a:solidFill>
+                  <a:srgbClr val="FF3621"/>
+                </a:solidFill>
+                <a:latin typeface="DM Sans"/>
+              </a:rPr>
+              <a:t>Q: Which image readings have needed human intervention?</a:t>
+            </a:r>
+          </a:p>
+          <a:p>
+            <a:pPr>
+              <a:spcAft>
+                <a:spcPts val="0"/>
+              </a:spcAft>
+            </a:pPr>
+            <a:r>
+              <a:rPr sz="1000">
+                <a:solidFill>
+                  <a:srgbClr val="1B3037"/>
+                </a:solidFill>
+                <a:latin typeface="Courier New"/>
+              </a:rPr>
+              <a:t>SELECT image_id, gauge_id, site, ai_value, human_value, unit, override_reason, reviewed_by, reviewed_at</a:t>
+            </a:r>
+          </a:p>
+          <a:p>
+            <a:pPr>
+              <a:spcAft>
+                <a:spcPts val="0"/>
+              </a:spcAft>
+            </a:pPr>
+            <a:r>
+              <a:rPr sz="1000">
+                <a:solidFill>
+                  <a:srgbClr val="1B3037"/>
+                </a:solidFill>
+                <a:latin typeface="Courier New"/>
+              </a:rPr>
+              <a:t>FROM ...gold_gauge_readings_final WHERE is_human_corrected = true ORDER BY reviewed_at DESC</a:t>
+            </a:r>
+          </a:p>
+          <a:p>
+            <a:pPr>
+              <a:spcAft>
+                <a:spcPts val="0"/>
+              </a:spcAft>
+            </a:pPr>
+            <a:r>
+              <a:rPr sz="1000">
+                <a:solidFill>
+                  <a:srgbClr val="1B3037"/>
+                </a:solidFill>
+                <a:latin typeface="Courier New"/>
+              </a:rPr>
+              <a:t>Answer: "1 image reading needed human intervention: gauge_009.jpg for gauge PI-3102 at Northbay Refinery.</a:t>
+            </a:r>
+          </a:p>
+          <a:p>
+            <a:pPr>
+              <a:spcAft>
+                <a:spcPts val="0"/>
+              </a:spcAft>
+            </a:pPr>
+            <a:r>
+              <a:rPr sz="1000">
+                <a:solidFill>
+                  <a:srgbClr val="1B3037"/>
+                </a:solidFill>
+                <a:latin typeface="Courier New"/>
+              </a:rPr>
+              <a:t>         The AI reading was 5.0 bar, the human-corrected reading was 1.0 bar ..." </a:t>
+            </a:r>
+          </a:p>
+        </p:txBody>
+      </p:sp>
+      <p:sp>
+        <p:nvSpPr>
+          <p:cNvPr id="7" name="TextBox 6"/>
+          <p:cNvSpPr txBox="1"/>
+          <p:nvPr/>
+        </p:nvSpPr>
+        <p:spPr>
+          <a:xfrm>
+            <a:off x="758952" y="6199632"/>
+            <a:ext cx="10661904" cy="274320"/>
+          </a:xfrm>
+          <a:prstGeom prst="rect">
+            <a:avLst/>
+          </a:prstGeom>
+          <a:noFill/>
+        </p:spPr>
+        <p:txBody>
+          <a:bodyPr wrap="square" anchor="t" lIns="45720" rIns="45720">
+            <a:spAutoFit/>
+          </a:bodyPr>
+          <a:lstStyle/>
+          <a:p>
+            <a:pPr algn="l"/>
+            <a:r>
+              <a:rPr sz="900" b="0">
+                <a:solidFill>
+                  <a:srgbClr val="5F6B70"/>
+                </a:solidFill>
+                <a:latin typeface="DM Sans"/>
+              </a:rPr>
+              <a:t>Captured 2026-10-07 15:34 UTC from the build workspace by src/setup/capture_evidence.py · full output in evidence/ (index: VALIDATION.md)</a:t>
+            </a:r>
+          </a:p>
+        </p:txBody>
+      </p:sp>
+    </p:spTree>
+  </p:cSld>
+  <p:clrMapOvr>
+    <a:masterClrMapping/>
+  </p:clrMapOvr>
+</p:sld>
+</file>
+
 <file path=ppt/slides/slide2.xml><?xml version="1.0" encoding="utf-8"?>
 <p:sld xmlns:a="http://schemas.openxmlformats.org/drawingml/2006/main" xmlns:p="http://schemas.openxmlformats.org/presentationml/2006/main" xmlns:r="http://schemas.openxmlformats.org/officeDocument/2006/relationships">
   <p:cSld>
@@ -17883,20 +19546,30 @@
           <a:lstStyle/>
           <a:p>
             <a:r>
-              <a:rPr sz="1600"/>
-              <a:t>Robot rounds keep ~2,200 operator hours a year out of process areas (2 rounds a day × ~3 hours)</a:t>
+              <a:rPr sz="1500" b="1">
+                <a:solidFill>
+                  <a:srgbClr val="FF3621"/>
+                </a:solidFill>
+              </a:rPr>
+              <a:t>Measured on: recordable injury rate (TRIR), process-safety events, plant availability, operating cost</a:t>
             </a:r>
           </a:p>
           <a:p>
             <a:r>
-              <a:rPr sz="1600"/>
-              <a:t>Vendor dependency removed: ~$15k a year on the platform vs. ~$180k in per-image fees</a:t>
+              <a:rPr sz="1500"/>
+              <a:t>Safety: ~2,200 operator hours a year kept out of process areas as robot rounds produce trusted readings</a:t>
             </a:r>
           </a:p>
           <a:p>
             <a:r>
-              <a:rPr sz="1600"/>
-              <a:t>Unexpectedly high pressures surfaced the same shift, not at the next manual round</a:t>
+              <a:rPr sz="1500"/>
+              <a:t>Availability: same-shift excursion warnings; one avoided hour of unplanned downtime ≈ $0.8M</a:t>
+            </a:r>
+          </a:p>
+          <a:p>
+            <a:r>
+              <a:rPr sz="1500"/>
+              <a:t>Operating cost: ~$15k a year on the platform vs. ~$180k in per-image vendor fees</a:t>
             </a:r>
           </a:p>
         </p:txBody>
@@ -17917,20 +19590,30 @@
           <a:lstStyle/>
           <a:p>
             <a:r>
-              <a:rPr sz="1600"/>
-              <a:t>One review queue, sorted by risk: low confidence, unreadable, unexpectedly high</a:t>
+              <a:rPr sz="1500" b="1">
+                <a:solidFill>
+                  <a:srgbClr val="FF3621"/>
+                </a:solidFill>
+              </a:rPr>
+              <a:t>Measured on: unplanned downtime hours, mean time between failures (MTBF), maintenance backlog</a:t>
             </a:r>
           </a:p>
           <a:p>
             <a:r>
-              <a:rPr sz="1600"/>
-              <a:t>Every correction audited (who, when, why) and fed back to the lakehouse</a:t>
+              <a:rPr sz="1500"/>
+              <a:t>Downtime and MTBF: excursions caught between rounds, with per-gauge trends to spot degradation early</a:t>
             </a:r>
           </a:p>
           <a:p>
             <a:r>
-              <a:rPr sz="1600"/>
-              <a:t>Ask in plain English: “Are any pressure readings unexpectedly high?”</a:t>
+              <a:rPr sz="1500"/>
+              <a:t>Backlog: one review queue sorted by risk; unexpectedly high readings become work orders</a:t>
+            </a:r>
+          </a:p>
+          <a:p>
+            <a:r>
+              <a:rPr sz="1500"/>
+              <a:t>Audit: every correction recorded (who, when, why) and answerable in Genie</a:t>
             </a:r>
           </a:p>
         </p:txBody>
@@ -17993,7 +19676,7 @@
           <a:lstStyle/>
           <a:p>
             <a:r>
-              <a:t>Built for the executive sponsor and the domain owner</a:t>
+              <a:t>Each lever mapped to the numbers each leader is measured on</a:t>
             </a:r>
           </a:p>
         </p:txBody>

</xml_diff>